<commit_message>
Added speaker ntoes for my parts
</commit_message>
<xml_diff>
--- a/Neuro-2.pptx
+++ b/Neuro-2.pptx
@@ -4,38 +4,41 @@
   <p:sldMasterIdLst>
     <p:sldMasterId id="2147483648" r:id="rId1"/>
   </p:sldMasterIdLst>
+  <p:notesMasterIdLst>
+    <p:notesMasterId r:id="rId31"/>
+  </p:notesMasterIdLst>
   <p:sldIdLst>
-    <p:sldId id="256" r:id="rId7"/>
-    <p:sldId id="257" r:id="rId8"/>
-    <p:sldId id="258" r:id="rId9"/>
-    <p:sldId id="259" r:id="rId10"/>
-    <p:sldId id="260" r:id="rId11"/>
-    <p:sldId id="261" r:id="rId12"/>
-    <p:sldId id="262" r:id="rId13"/>
-    <p:sldId id="263" r:id="rId14"/>
-    <p:sldId id="264" r:id="rId15"/>
-    <p:sldId id="265" r:id="rId16"/>
-    <p:sldId id="266" r:id="rId17"/>
-    <p:sldId id="267" r:id="rId18"/>
-    <p:sldId id="268" r:id="rId19"/>
-    <p:sldId id="269" r:id="rId20"/>
-    <p:sldId id="270" r:id="rId21"/>
-    <p:sldId id="271" r:id="rId22"/>
-    <p:sldId id="272" r:id="rId23"/>
-    <p:sldId id="273" r:id="rId24"/>
-    <p:sldId id="274" r:id="rId25"/>
-    <p:sldId id="275" r:id="rId26"/>
-    <p:sldId id="276" r:id="rId27"/>
-    <p:sldId id="277" r:id="rId28"/>
-    <p:sldId id="278" r:id="rId29"/>
-    <p:sldId id="279" r:id="rId30"/>
-    <p:sldId id="280" r:id="rId31"/>
-    <p:sldId id="281" r:id="rId32"/>
-    <p:sldId id="282" r:id="rId33"/>
-    <p:sldId id="283" r:id="rId34"/>
-    <p:sldId id="284" r:id="rId35"/>
+    <p:sldId id="256" r:id="rId2"/>
+    <p:sldId id="257" r:id="rId3"/>
+    <p:sldId id="258" r:id="rId4"/>
+    <p:sldId id="259" r:id="rId5"/>
+    <p:sldId id="260" r:id="rId6"/>
+    <p:sldId id="261" r:id="rId7"/>
+    <p:sldId id="262" r:id="rId8"/>
+    <p:sldId id="263" r:id="rId9"/>
+    <p:sldId id="264" r:id="rId10"/>
+    <p:sldId id="265" r:id="rId11"/>
+    <p:sldId id="266" r:id="rId12"/>
+    <p:sldId id="267" r:id="rId13"/>
+    <p:sldId id="268" r:id="rId14"/>
+    <p:sldId id="269" r:id="rId15"/>
+    <p:sldId id="270" r:id="rId16"/>
+    <p:sldId id="271" r:id="rId17"/>
+    <p:sldId id="272" r:id="rId18"/>
+    <p:sldId id="273" r:id="rId19"/>
+    <p:sldId id="274" r:id="rId20"/>
+    <p:sldId id="275" r:id="rId21"/>
+    <p:sldId id="276" r:id="rId22"/>
+    <p:sldId id="277" r:id="rId23"/>
+    <p:sldId id="278" r:id="rId24"/>
+    <p:sldId id="279" r:id="rId25"/>
+    <p:sldId id="280" r:id="rId26"/>
+    <p:sldId id="281" r:id="rId27"/>
+    <p:sldId id="282" r:id="rId28"/>
+    <p:sldId id="283" r:id="rId29"/>
+    <p:sldId id="284" r:id="rId30"/>
   </p:sldIdLst>
-  <p:sldSz cx="12191999" cy="6860418" type="screen4x3"/>
+  <p:sldSz cx="12192000" cy="6861175"/>
   <p:notesSz cx="6858000" cy="9144000"/>
   <p:defaultTextStyle>
     <a:defPPr>
@@ -132,7 +135,802 @@
       </a:defRPr>
     </a:lvl9pPr>
   </p:defaultTextStyle>
+  <p:extLst>
+    <p:ext uri="{EFAFB233-063F-42B5-8137-9DF3F51BA10A}">
+      <p15:sldGuideLst xmlns:p15="http://schemas.microsoft.com/office/powerpoint/2012/main">
+        <p15:guide id="1" orient="horz" pos="2160">
+          <p15:clr>
+            <a:srgbClr val="A4A3A4"/>
+          </p15:clr>
+        </p15:guide>
+        <p15:guide id="2" pos="2880">
+          <p15:clr>
+            <a:srgbClr val="A4A3A4"/>
+          </p15:clr>
+        </p15:guide>
+      </p15:sldGuideLst>
+    </p:ext>
+  </p:extLst>
 </p:presentation>
+</file>
+
+<file path=ppt/notesMasters/notesMaster1.xml><?xml version="1.0" encoding="utf-8"?>
+<p:notesMaster xmlns:a="http://schemas.openxmlformats.org/drawingml/2006/main" xmlns:r="http://schemas.openxmlformats.org/officeDocument/2006/relationships" xmlns:p="http://schemas.openxmlformats.org/presentationml/2006/main">
+  <p:cSld>
+    <p:bg>
+      <p:bgRef idx="1001">
+        <a:schemeClr val="bg1"/>
+      </p:bgRef>
+    </p:bg>
+    <p:spTree>
+      <p:nvGrpSpPr>
+        <p:cNvPr id="1" name=""/>
+        <p:cNvGrpSpPr/>
+        <p:nvPr/>
+      </p:nvGrpSpPr>
+      <p:grpSpPr>
+        <a:xfrm>
+          <a:off x="0" y="0"/>
+          <a:ext cx="0" cy="0"/>
+          <a:chOff x="0" y="0"/>
+          <a:chExt cx="0" cy="0"/>
+        </a:xfrm>
+      </p:grpSpPr>
+      <p:sp>
+        <p:nvSpPr>
+          <p:cNvPr id="2" name="Header Placeholder 1"/>
+          <p:cNvSpPr>
+            <a:spLocks noGrp="1"/>
+          </p:cNvSpPr>
+          <p:nvPr>
+            <p:ph type="hdr" sz="quarter"/>
+          </p:nvPr>
+        </p:nvSpPr>
+        <p:spPr>
+          <a:xfrm>
+            <a:off x="0" y="0"/>
+            <a:ext cx="2971800" cy="458788"/>
+          </a:xfrm>
+          <a:prstGeom prst="rect">
+            <a:avLst/>
+          </a:prstGeom>
+        </p:spPr>
+        <p:txBody>
+          <a:bodyPr vert="horz" lIns="91440" tIns="45720" rIns="91440" bIns="45720" rtlCol="0"/>
+          <a:lstStyle>
+            <a:lvl1pPr algn="l">
+              <a:defRPr sz="1200"/>
+            </a:lvl1pPr>
+          </a:lstStyle>
+          <a:p>
+            <a:endParaRPr lang="en-GB"/>
+          </a:p>
+        </p:txBody>
+      </p:sp>
+      <p:sp>
+        <p:nvSpPr>
+          <p:cNvPr id="3" name="Date Placeholder 2"/>
+          <p:cNvSpPr>
+            <a:spLocks noGrp="1"/>
+          </p:cNvSpPr>
+          <p:nvPr>
+            <p:ph type="dt" idx="1"/>
+          </p:nvPr>
+        </p:nvSpPr>
+        <p:spPr>
+          <a:xfrm>
+            <a:off x="3884613" y="0"/>
+            <a:ext cx="2971800" cy="458788"/>
+          </a:xfrm>
+          <a:prstGeom prst="rect">
+            <a:avLst/>
+          </a:prstGeom>
+        </p:spPr>
+        <p:txBody>
+          <a:bodyPr vert="horz" lIns="91440" tIns="45720" rIns="91440" bIns="45720" rtlCol="0"/>
+          <a:lstStyle>
+            <a:lvl1pPr algn="r">
+              <a:defRPr sz="1200"/>
+            </a:lvl1pPr>
+          </a:lstStyle>
+          <a:p>
+            <a:fld id="{536A4B2F-BC9D-41E1-8407-27B6D02BD224}" type="datetimeFigureOut">
+              <a:rPr lang="en-GB" smtClean="0"/>
+              <a:t>13/05/2026</a:t>
+            </a:fld>
+            <a:endParaRPr lang="en-GB"/>
+          </a:p>
+        </p:txBody>
+      </p:sp>
+      <p:sp>
+        <p:nvSpPr>
+          <p:cNvPr id="4" name="Slide Image Placeholder 3"/>
+          <p:cNvSpPr>
+            <a:spLocks noGrp="1" noRot="1" noChangeAspect="1"/>
+          </p:cNvSpPr>
+          <p:nvPr>
+            <p:ph type="sldImg" idx="2"/>
+          </p:nvPr>
+        </p:nvSpPr>
+        <p:spPr>
+          <a:xfrm>
+            <a:off x="687388" y="1143000"/>
+            <a:ext cx="5483225" cy="3086100"/>
+          </a:xfrm>
+          <a:prstGeom prst="rect">
+            <a:avLst/>
+          </a:prstGeom>
+          <a:noFill/>
+          <a:ln w="12700">
+            <a:solidFill>
+              <a:prstClr val="black"/>
+            </a:solidFill>
+          </a:ln>
+        </p:spPr>
+        <p:txBody>
+          <a:bodyPr vert="horz" lIns="91440" tIns="45720" rIns="91440" bIns="45720" rtlCol="0" anchor="ctr"/>
+          <a:lstStyle/>
+          <a:p>
+            <a:endParaRPr lang="en-GB"/>
+          </a:p>
+        </p:txBody>
+      </p:sp>
+      <p:sp>
+        <p:nvSpPr>
+          <p:cNvPr id="5" name="Notes Placeholder 4"/>
+          <p:cNvSpPr>
+            <a:spLocks noGrp="1"/>
+          </p:cNvSpPr>
+          <p:nvPr>
+            <p:ph type="body" sz="quarter" idx="3"/>
+          </p:nvPr>
+        </p:nvSpPr>
+        <p:spPr>
+          <a:xfrm>
+            <a:off x="685800" y="4400550"/>
+            <a:ext cx="5486400" cy="3600450"/>
+          </a:xfrm>
+          <a:prstGeom prst="rect">
+            <a:avLst/>
+          </a:prstGeom>
+        </p:spPr>
+        <p:txBody>
+          <a:bodyPr vert="horz" lIns="91440" tIns="45720" rIns="91440" bIns="45720" rtlCol="0"/>
+          <a:lstStyle/>
+          <a:p>
+            <a:pPr lvl="0"/>
+            <a:r>
+              <a:rPr lang="en-GB"/>
+              <a:t>Click to edit Master text styles</a:t>
+            </a:r>
+          </a:p>
+          <a:p>
+            <a:pPr lvl="1"/>
+            <a:r>
+              <a:rPr lang="en-GB"/>
+              <a:t>Second level</a:t>
+            </a:r>
+          </a:p>
+          <a:p>
+            <a:pPr lvl="2"/>
+            <a:r>
+              <a:rPr lang="en-GB"/>
+              <a:t>Third level</a:t>
+            </a:r>
+          </a:p>
+          <a:p>
+            <a:pPr lvl="3"/>
+            <a:r>
+              <a:rPr lang="en-GB"/>
+              <a:t>Fourth level</a:t>
+            </a:r>
+          </a:p>
+          <a:p>
+            <a:pPr lvl="4"/>
+            <a:r>
+              <a:rPr lang="en-GB"/>
+              <a:t>Fifth level</a:t>
+            </a:r>
+          </a:p>
+        </p:txBody>
+      </p:sp>
+      <p:sp>
+        <p:nvSpPr>
+          <p:cNvPr id="6" name="Footer Placeholder 5"/>
+          <p:cNvSpPr>
+            <a:spLocks noGrp="1"/>
+          </p:cNvSpPr>
+          <p:nvPr>
+            <p:ph type="ftr" sz="quarter" idx="4"/>
+          </p:nvPr>
+        </p:nvSpPr>
+        <p:spPr>
+          <a:xfrm>
+            <a:off x="0" y="8685213"/>
+            <a:ext cx="2971800" cy="458787"/>
+          </a:xfrm>
+          <a:prstGeom prst="rect">
+            <a:avLst/>
+          </a:prstGeom>
+        </p:spPr>
+        <p:txBody>
+          <a:bodyPr vert="horz" lIns="91440" tIns="45720" rIns="91440" bIns="45720" rtlCol="0" anchor="b"/>
+          <a:lstStyle>
+            <a:lvl1pPr algn="l">
+              <a:defRPr sz="1200"/>
+            </a:lvl1pPr>
+          </a:lstStyle>
+          <a:p>
+            <a:endParaRPr lang="en-GB"/>
+          </a:p>
+        </p:txBody>
+      </p:sp>
+      <p:sp>
+        <p:nvSpPr>
+          <p:cNvPr id="7" name="Slide Number Placeholder 6"/>
+          <p:cNvSpPr>
+            <a:spLocks noGrp="1"/>
+          </p:cNvSpPr>
+          <p:nvPr>
+            <p:ph type="sldNum" sz="quarter" idx="5"/>
+          </p:nvPr>
+        </p:nvSpPr>
+        <p:spPr>
+          <a:xfrm>
+            <a:off x="3884613" y="8685213"/>
+            <a:ext cx="2971800" cy="458787"/>
+          </a:xfrm>
+          <a:prstGeom prst="rect">
+            <a:avLst/>
+          </a:prstGeom>
+        </p:spPr>
+        <p:txBody>
+          <a:bodyPr vert="horz" lIns="91440" tIns="45720" rIns="91440" bIns="45720" rtlCol="0" anchor="b"/>
+          <a:lstStyle>
+            <a:lvl1pPr algn="r">
+              <a:defRPr sz="1200"/>
+            </a:lvl1pPr>
+          </a:lstStyle>
+          <a:p>
+            <a:fld id="{C470CF08-691C-47BD-8323-C27169DE5690}" type="slidenum">
+              <a:rPr lang="en-GB" smtClean="0"/>
+              <a:t>‹#›</a:t>
+            </a:fld>
+            <a:endParaRPr lang="en-GB"/>
+          </a:p>
+        </p:txBody>
+      </p:sp>
+    </p:spTree>
+    <p:extLst>
+      <p:ext uri="{BB962C8B-B14F-4D97-AF65-F5344CB8AC3E}">
+        <p14:creationId xmlns:p14="http://schemas.microsoft.com/office/powerpoint/2010/main" val="3109509492"/>
+      </p:ext>
+    </p:extLst>
+  </p:cSld>
+  <p:clrMap bg1="lt1" tx1="dk1" bg2="lt2" tx2="dk2" accent1="accent1" accent2="accent2" accent3="accent3" accent4="accent4" accent5="accent5" accent6="accent6" hlink="hlink" folHlink="folHlink"/>
+  <p:notesStyle>
+    <a:lvl1pPr marL="0" algn="l" defTabSz="914400" rtl="0" eaLnBrk="1" latinLnBrk="0" hangingPunct="1">
+      <a:defRPr sz="1200" kern="1200">
+        <a:solidFill>
+          <a:schemeClr val="tx1"/>
+        </a:solidFill>
+        <a:latin typeface="+mn-lt"/>
+        <a:ea typeface="+mn-ea"/>
+        <a:cs typeface="+mn-cs"/>
+      </a:defRPr>
+    </a:lvl1pPr>
+    <a:lvl2pPr marL="457200" algn="l" defTabSz="914400" rtl="0" eaLnBrk="1" latinLnBrk="0" hangingPunct="1">
+      <a:defRPr sz="1200" kern="1200">
+        <a:solidFill>
+          <a:schemeClr val="tx1"/>
+        </a:solidFill>
+        <a:latin typeface="+mn-lt"/>
+        <a:ea typeface="+mn-ea"/>
+        <a:cs typeface="+mn-cs"/>
+      </a:defRPr>
+    </a:lvl2pPr>
+    <a:lvl3pPr marL="914400" algn="l" defTabSz="914400" rtl="0" eaLnBrk="1" latinLnBrk="0" hangingPunct="1">
+      <a:defRPr sz="1200" kern="1200">
+        <a:solidFill>
+          <a:schemeClr val="tx1"/>
+        </a:solidFill>
+        <a:latin typeface="+mn-lt"/>
+        <a:ea typeface="+mn-ea"/>
+        <a:cs typeface="+mn-cs"/>
+      </a:defRPr>
+    </a:lvl3pPr>
+    <a:lvl4pPr marL="1371600" algn="l" defTabSz="914400" rtl="0" eaLnBrk="1" latinLnBrk="0" hangingPunct="1">
+      <a:defRPr sz="1200" kern="1200">
+        <a:solidFill>
+          <a:schemeClr val="tx1"/>
+        </a:solidFill>
+        <a:latin typeface="+mn-lt"/>
+        <a:ea typeface="+mn-ea"/>
+        <a:cs typeface="+mn-cs"/>
+      </a:defRPr>
+    </a:lvl4pPr>
+    <a:lvl5pPr marL="1828800" algn="l" defTabSz="914400" rtl="0" eaLnBrk="1" latinLnBrk="0" hangingPunct="1">
+      <a:defRPr sz="1200" kern="1200">
+        <a:solidFill>
+          <a:schemeClr val="tx1"/>
+        </a:solidFill>
+        <a:latin typeface="+mn-lt"/>
+        <a:ea typeface="+mn-ea"/>
+        <a:cs typeface="+mn-cs"/>
+      </a:defRPr>
+    </a:lvl5pPr>
+    <a:lvl6pPr marL="2286000" algn="l" defTabSz="914400" rtl="0" eaLnBrk="1" latinLnBrk="0" hangingPunct="1">
+      <a:defRPr sz="1200" kern="1200">
+        <a:solidFill>
+          <a:schemeClr val="tx1"/>
+        </a:solidFill>
+        <a:latin typeface="+mn-lt"/>
+        <a:ea typeface="+mn-ea"/>
+        <a:cs typeface="+mn-cs"/>
+      </a:defRPr>
+    </a:lvl6pPr>
+    <a:lvl7pPr marL="2743200" algn="l" defTabSz="914400" rtl="0" eaLnBrk="1" latinLnBrk="0" hangingPunct="1">
+      <a:defRPr sz="1200" kern="1200">
+        <a:solidFill>
+          <a:schemeClr val="tx1"/>
+        </a:solidFill>
+        <a:latin typeface="+mn-lt"/>
+        <a:ea typeface="+mn-ea"/>
+        <a:cs typeface="+mn-cs"/>
+      </a:defRPr>
+    </a:lvl7pPr>
+    <a:lvl8pPr marL="3200400" algn="l" defTabSz="914400" rtl="0" eaLnBrk="1" latinLnBrk="0" hangingPunct="1">
+      <a:defRPr sz="1200" kern="1200">
+        <a:solidFill>
+          <a:schemeClr val="tx1"/>
+        </a:solidFill>
+        <a:latin typeface="+mn-lt"/>
+        <a:ea typeface="+mn-ea"/>
+        <a:cs typeface="+mn-cs"/>
+      </a:defRPr>
+    </a:lvl8pPr>
+    <a:lvl9pPr marL="3657600" algn="l" defTabSz="914400" rtl="0" eaLnBrk="1" latinLnBrk="0" hangingPunct="1">
+      <a:defRPr sz="1200" kern="1200">
+        <a:solidFill>
+          <a:schemeClr val="tx1"/>
+        </a:solidFill>
+        <a:latin typeface="+mn-lt"/>
+        <a:ea typeface="+mn-ea"/>
+        <a:cs typeface="+mn-cs"/>
+      </a:defRPr>
+    </a:lvl9pPr>
+  </p:notesStyle>
+</p:notesMaster>
+</file>
+
+<file path=ppt/notesSlides/notesSlide1.xml><?xml version="1.0" encoding="utf-8"?>
+<p:notes xmlns:a="http://schemas.openxmlformats.org/drawingml/2006/main" xmlns:r="http://schemas.openxmlformats.org/officeDocument/2006/relationships" xmlns:p="http://schemas.openxmlformats.org/presentationml/2006/main">
+  <p:cSld>
+    <p:spTree>
+      <p:nvGrpSpPr>
+        <p:cNvPr id="1" name=""/>
+        <p:cNvGrpSpPr/>
+        <p:nvPr/>
+      </p:nvGrpSpPr>
+      <p:grpSpPr>
+        <a:xfrm>
+          <a:off x="0" y="0"/>
+          <a:ext cx="0" cy="0"/>
+          <a:chOff x="0" y="0"/>
+          <a:chExt cx="0" cy="0"/>
+        </a:xfrm>
+      </p:grpSpPr>
+      <p:sp>
+        <p:nvSpPr>
+          <p:cNvPr id="2" name="Slide Image Placeholder 1"/>
+          <p:cNvSpPr>
+            <a:spLocks noGrp="1" noRot="1" noChangeAspect="1"/>
+          </p:cNvSpPr>
+          <p:nvPr>
+            <p:ph type="sldImg"/>
+          </p:nvPr>
+        </p:nvSpPr>
+        <p:spPr/>
+      </p:sp>
+      <p:sp>
+        <p:nvSpPr>
+          <p:cNvPr id="3" name="Notes Placeholder 2"/>
+          <p:cNvSpPr>
+            <a:spLocks noGrp="1"/>
+          </p:cNvSpPr>
+          <p:nvPr>
+            <p:ph type="body" idx="1"/>
+          </p:nvPr>
+        </p:nvSpPr>
+        <p:spPr/>
+        <p:txBody>
+          <a:bodyPr/>
+          <a:lstStyle/>
+          <a:p>
+            <a:r>
+              <a:rPr lang="en-GB" sz="1200" b="0" i="0" kern="1200" dirty="0">
+                <a:solidFill>
+                  <a:schemeClr val="tx1"/>
+                </a:solidFill>
+                <a:effectLst/>
+                <a:latin typeface="+mn-lt"/>
+                <a:ea typeface="+mn-ea"/>
+                <a:cs typeface="+mn-cs"/>
+              </a:rPr>
+              <a:t>Now we move from pair-level effects to network-level structure. Up to this point, the main result was that directly connected pairs are more functionally similar. The question here is stricter: do the two whole networks have similar topology</a:t>
+            </a:r>
+            <a:endParaRPr lang="en-GB" dirty="0"/>
+          </a:p>
+        </p:txBody>
+      </p:sp>
+      <p:sp>
+        <p:nvSpPr>
+          <p:cNvPr id="4" name="Slide Number Placeholder 3"/>
+          <p:cNvSpPr>
+            <a:spLocks noGrp="1"/>
+          </p:cNvSpPr>
+          <p:nvPr>
+            <p:ph type="sldNum" sz="quarter" idx="5"/>
+          </p:nvPr>
+        </p:nvSpPr>
+        <p:spPr/>
+        <p:txBody>
+          <a:bodyPr/>
+          <a:lstStyle/>
+          <a:p>
+            <a:fld id="{C470CF08-691C-47BD-8323-C27169DE5690}" type="slidenum">
+              <a:rPr lang="en-GB" smtClean="0"/>
+              <a:t>16</a:t>
+            </a:fld>
+            <a:endParaRPr lang="en-GB"/>
+          </a:p>
+        </p:txBody>
+      </p:sp>
+    </p:spTree>
+    <p:extLst>
+      <p:ext uri="{BB962C8B-B14F-4D97-AF65-F5344CB8AC3E}">
+        <p14:creationId xmlns:p14="http://schemas.microsoft.com/office/powerpoint/2010/main" val="4242617154"/>
+      </p:ext>
+    </p:extLst>
+  </p:cSld>
+  <p:clrMapOvr>
+    <a:masterClrMapping/>
+  </p:clrMapOvr>
+</p:notes>
+</file>
+
+<file path=ppt/notesSlides/notesSlide2.xml><?xml version="1.0" encoding="utf-8"?>
+<p:notes xmlns:a="http://schemas.openxmlformats.org/drawingml/2006/main" xmlns:r="http://schemas.openxmlformats.org/officeDocument/2006/relationships" xmlns:p="http://schemas.openxmlformats.org/presentationml/2006/main">
+  <p:cSld>
+    <p:spTree>
+      <p:nvGrpSpPr>
+        <p:cNvPr id="1" name=""/>
+        <p:cNvGrpSpPr/>
+        <p:nvPr/>
+      </p:nvGrpSpPr>
+      <p:grpSpPr>
+        <a:xfrm>
+          <a:off x="0" y="0"/>
+          <a:ext cx="0" cy="0"/>
+          <a:chOff x="0" y="0"/>
+          <a:chExt cx="0" cy="0"/>
+        </a:xfrm>
+      </p:grpSpPr>
+      <p:sp>
+        <p:nvSpPr>
+          <p:cNvPr id="2" name="Slide Image Placeholder 1"/>
+          <p:cNvSpPr>
+            <a:spLocks noGrp="1" noRot="1" noChangeAspect="1"/>
+          </p:cNvSpPr>
+          <p:nvPr>
+            <p:ph type="sldImg"/>
+          </p:nvPr>
+        </p:nvSpPr>
+        <p:spPr/>
+      </p:sp>
+      <p:sp>
+        <p:nvSpPr>
+          <p:cNvPr id="3" name="Notes Placeholder 2"/>
+          <p:cNvSpPr>
+            <a:spLocks noGrp="1"/>
+          </p:cNvSpPr>
+          <p:nvPr>
+            <p:ph type="body" idx="1"/>
+          </p:nvPr>
+        </p:nvSpPr>
+        <p:spPr/>
+        <p:txBody>
+          <a:bodyPr/>
+          <a:lstStyle/>
+          <a:p>
+            <a:r>
+              <a:rPr lang="en-GB" sz="1200" b="0" i="0" kern="1200" dirty="0">
+                <a:solidFill>
+                  <a:schemeClr val="tx1"/>
+                </a:solidFill>
+                <a:effectLst/>
+                <a:latin typeface="+mn-lt"/>
+                <a:ea typeface="+mn-ea"/>
+                <a:cs typeface="+mn-cs"/>
+              </a:rPr>
+              <a:t>At the topology level, we are no longer asking whether one connected pair has higher correlation than one unconnected pair. We are asking whether structurally important neurons are also functionally important. So we compare node-level quantities like degree, synaptic strength, and mean functional coupling, and also graph-level quantities like clustering. The main caveat is that the two networks are very different objects: the structural graph is sparse, directed, and synapse-weighted, while the functional graph is dense, symmetric, and signed.</a:t>
+            </a:r>
+            <a:endParaRPr lang="en-GB" dirty="0"/>
+          </a:p>
+        </p:txBody>
+      </p:sp>
+      <p:sp>
+        <p:nvSpPr>
+          <p:cNvPr id="4" name="Slide Number Placeholder 3"/>
+          <p:cNvSpPr>
+            <a:spLocks noGrp="1"/>
+          </p:cNvSpPr>
+          <p:nvPr>
+            <p:ph type="sldNum" sz="quarter" idx="5"/>
+          </p:nvPr>
+        </p:nvSpPr>
+        <p:spPr/>
+        <p:txBody>
+          <a:bodyPr/>
+          <a:lstStyle/>
+          <a:p>
+            <a:fld id="{C470CF08-691C-47BD-8323-C27169DE5690}" type="slidenum">
+              <a:rPr lang="en-GB" smtClean="0"/>
+              <a:t>17</a:t>
+            </a:fld>
+            <a:endParaRPr lang="en-GB"/>
+          </a:p>
+        </p:txBody>
+      </p:sp>
+    </p:spTree>
+    <p:extLst>
+      <p:ext uri="{BB962C8B-B14F-4D97-AF65-F5344CB8AC3E}">
+        <p14:creationId xmlns:p14="http://schemas.microsoft.com/office/powerpoint/2010/main" val="56845704"/>
+      </p:ext>
+    </p:extLst>
+  </p:cSld>
+  <p:clrMapOvr>
+    <a:masterClrMapping/>
+  </p:clrMapOvr>
+</p:notes>
+</file>
+
+<file path=ppt/notesSlides/notesSlide3.xml><?xml version="1.0" encoding="utf-8"?>
+<p:notes xmlns:a="http://schemas.openxmlformats.org/drawingml/2006/main" xmlns:r="http://schemas.openxmlformats.org/officeDocument/2006/relationships" xmlns:p="http://schemas.openxmlformats.org/presentationml/2006/main">
+  <p:cSld>
+    <p:spTree>
+      <p:nvGrpSpPr>
+        <p:cNvPr id="1" name=""/>
+        <p:cNvGrpSpPr/>
+        <p:nvPr/>
+      </p:nvGrpSpPr>
+      <p:grpSpPr>
+        <a:xfrm>
+          <a:off x="0" y="0"/>
+          <a:ext cx="0" cy="0"/>
+          <a:chOff x="0" y="0"/>
+          <a:chExt cx="0" cy="0"/>
+        </a:xfrm>
+      </p:grpSpPr>
+      <p:sp>
+        <p:nvSpPr>
+          <p:cNvPr id="2" name="Slide Image Placeholder 1"/>
+          <p:cNvSpPr>
+            <a:spLocks noGrp="1" noRot="1" noChangeAspect="1"/>
+          </p:cNvSpPr>
+          <p:nvPr>
+            <p:ph type="sldImg"/>
+          </p:nvPr>
+        </p:nvSpPr>
+        <p:spPr/>
+      </p:sp>
+      <p:sp>
+        <p:nvSpPr>
+          <p:cNvPr id="3" name="Notes Placeholder 2"/>
+          <p:cNvSpPr>
+            <a:spLocks noGrp="1"/>
+          </p:cNvSpPr>
+          <p:nvPr>
+            <p:ph type="body" idx="1"/>
+          </p:nvPr>
+        </p:nvSpPr>
+        <p:spPr/>
+        <p:txBody>
+          <a:bodyPr/>
+          <a:lstStyle/>
+          <a:p>
+            <a:r>
+              <a:rPr lang="en-GB" sz="1200" b="0" i="0" kern="1200" dirty="0">
+                <a:solidFill>
+                  <a:schemeClr val="tx1"/>
+                </a:solidFill>
+                <a:effectLst/>
+                <a:latin typeface="+mn-lt"/>
+                <a:ea typeface="+mn-ea"/>
+                <a:cs typeface="+mn-cs"/>
+              </a:rPr>
+              <a:t>H7 asks whether structural hubs are functional hubs. The primary result is a partial Spearman correlation of about +0.110 after controlling for distance and area. That is statistically detectable, but it only explains about 1.2% of rank variance, so the effect is very small. When we add stricter controls like cell type or layer, the correlation drops to around +0.06 and is no longer robust after correction. Also, if we ignore sign and use absolute functional correlation, the relationship is basically gone. So the conclusion is not broad hub-to-hub matching, but a narrow weak signed alignment</a:t>
+            </a:r>
+            <a:endParaRPr lang="en-GB" dirty="0"/>
+          </a:p>
+        </p:txBody>
+      </p:sp>
+      <p:sp>
+        <p:nvSpPr>
+          <p:cNvPr id="4" name="Slide Number Placeholder 3"/>
+          <p:cNvSpPr>
+            <a:spLocks noGrp="1"/>
+          </p:cNvSpPr>
+          <p:nvPr>
+            <p:ph type="sldNum" sz="quarter" idx="5"/>
+          </p:nvPr>
+        </p:nvSpPr>
+        <p:spPr/>
+        <p:txBody>
+          <a:bodyPr/>
+          <a:lstStyle/>
+          <a:p>
+            <a:fld id="{C470CF08-691C-47BD-8323-C27169DE5690}" type="slidenum">
+              <a:rPr lang="en-GB" smtClean="0"/>
+              <a:t>18</a:t>
+            </a:fld>
+            <a:endParaRPr lang="en-GB"/>
+          </a:p>
+        </p:txBody>
+      </p:sp>
+    </p:spTree>
+    <p:extLst>
+      <p:ext uri="{BB962C8B-B14F-4D97-AF65-F5344CB8AC3E}">
+        <p14:creationId xmlns:p14="http://schemas.microsoft.com/office/powerpoint/2010/main" val="3944687126"/>
+      </p:ext>
+    </p:extLst>
+  </p:cSld>
+  <p:clrMapOvr>
+    <a:masterClrMapping/>
+  </p:clrMapOvr>
+</p:notes>
+</file>
+
+<file path=ppt/notesSlides/notesSlide4.xml><?xml version="1.0" encoding="utf-8"?>
+<p:notes xmlns:a="http://schemas.openxmlformats.org/drawingml/2006/main" xmlns:r="http://schemas.openxmlformats.org/officeDocument/2006/relationships" xmlns:p="http://schemas.openxmlformats.org/presentationml/2006/main">
+  <p:cSld>
+    <p:spTree>
+      <p:nvGrpSpPr>
+        <p:cNvPr id="1" name=""/>
+        <p:cNvGrpSpPr/>
+        <p:nvPr/>
+      </p:nvGrpSpPr>
+      <p:grpSpPr>
+        <a:xfrm>
+          <a:off x="0" y="0"/>
+          <a:ext cx="0" cy="0"/>
+          <a:chOff x="0" y="0"/>
+          <a:chExt cx="0" cy="0"/>
+        </a:xfrm>
+      </p:grpSpPr>
+      <p:sp>
+        <p:nvSpPr>
+          <p:cNvPr id="2" name="Slide Image Placeholder 1"/>
+          <p:cNvSpPr>
+            <a:spLocks noGrp="1" noRot="1" noChangeAspect="1"/>
+          </p:cNvSpPr>
+          <p:nvPr>
+            <p:ph type="sldImg"/>
+          </p:nvPr>
+        </p:nvSpPr>
+        <p:spPr/>
+      </p:sp>
+      <p:sp>
+        <p:nvSpPr>
+          <p:cNvPr id="3" name="Notes Placeholder 2"/>
+          <p:cNvSpPr>
+            <a:spLocks noGrp="1"/>
+          </p:cNvSpPr>
+          <p:nvPr>
+            <p:ph type="body" idx="1"/>
+          </p:nvPr>
+        </p:nvSpPr>
+        <p:spPr/>
+        <p:txBody>
+          <a:bodyPr/>
+          <a:lstStyle/>
+          <a:p>
+            <a:r>
+              <a:rPr lang="en-GB" sz="1200" b="0" i="0" kern="1200" dirty="0">
+                <a:solidFill>
+                  <a:schemeClr val="tx1"/>
+                </a:solidFill>
+                <a:effectLst/>
+                <a:latin typeface="+mn-lt"/>
+                <a:ea typeface="+mn-ea"/>
+                <a:cs typeface="+mn-cs"/>
+              </a:rPr>
+              <a:t>Because the functional matrix is dense, we also tried turning it into a sparse graph by thresholding it at densities matched to the structural graph. Across thresholds from 0.5x to 4x structural density, degree and strength coupling stay near zero, with maximum rho only around 0.03 and all p-values above 0.3. Clustering also looks very different: structural clustering is about 0.071, while functional clustering is around 0.27 to 0.33. So even after forcing the graphs to comparable densities, their topology does not match</a:t>
+            </a:r>
+            <a:br>
+              <a:rPr lang="en-GB" sz="1200" b="0" i="0" kern="1200" dirty="0">
+                <a:solidFill>
+                  <a:schemeClr val="tx1"/>
+                </a:solidFill>
+                <a:effectLst/>
+                <a:latin typeface="+mn-lt"/>
+                <a:ea typeface="+mn-ea"/>
+                <a:cs typeface="+mn-cs"/>
+              </a:rPr>
+            </a:br>
+            <a:br>
+              <a:rPr lang="en-GB" sz="1200" b="0" i="0" kern="1200" dirty="0">
+                <a:solidFill>
+                  <a:schemeClr val="tx1"/>
+                </a:solidFill>
+                <a:effectLst/>
+                <a:latin typeface="+mn-lt"/>
+                <a:ea typeface="+mn-ea"/>
+                <a:cs typeface="+mn-cs"/>
+              </a:rPr>
+            </a:br>
+            <a:r>
+              <a:rPr lang="en-GB" sz="1200" b="0" i="0" kern="1200" dirty="0">
+                <a:solidFill>
+                  <a:schemeClr val="tx1"/>
+                </a:solidFill>
+                <a:effectLst/>
+                <a:latin typeface="+mn-lt"/>
+                <a:ea typeface="+mn-ea"/>
+                <a:cs typeface="+mn-cs"/>
+              </a:rPr>
+              <a:t>So the overall message is: connectivity predicts function at the pair level, but the structural and functional networks are not topologically equivalent. </a:t>
+            </a:r>
+            <a:r>
+              <a:rPr lang="en-GB" sz="1200" b="0" i="0" kern="1200">
+                <a:solidFill>
+                  <a:schemeClr val="tx1"/>
+                </a:solidFill>
+                <a:effectLst/>
+                <a:latin typeface="+mn-lt"/>
+                <a:ea typeface="+mn-ea"/>
+                <a:cs typeface="+mn-cs"/>
+              </a:rPr>
+              <a:t>Anatomy shifts functional similarity locally, but it does not reproduce the global organization of the functional correlation network</a:t>
+            </a:r>
+            <a:endParaRPr lang="en-GB" dirty="0"/>
+          </a:p>
+        </p:txBody>
+      </p:sp>
+      <p:sp>
+        <p:nvSpPr>
+          <p:cNvPr id="4" name="Slide Number Placeholder 3"/>
+          <p:cNvSpPr>
+            <a:spLocks noGrp="1"/>
+          </p:cNvSpPr>
+          <p:nvPr>
+            <p:ph type="sldNum" sz="quarter" idx="5"/>
+          </p:nvPr>
+        </p:nvSpPr>
+        <p:spPr/>
+        <p:txBody>
+          <a:bodyPr/>
+          <a:lstStyle/>
+          <a:p>
+            <a:fld id="{C470CF08-691C-47BD-8323-C27169DE5690}" type="slidenum">
+              <a:rPr lang="en-GB" smtClean="0"/>
+              <a:t>19</a:t>
+            </a:fld>
+            <a:endParaRPr lang="en-GB"/>
+          </a:p>
+        </p:txBody>
+      </p:sp>
+    </p:spTree>
+    <p:extLst>
+      <p:ext uri="{BB962C8B-B14F-4D97-AF65-F5344CB8AC3E}">
+        <p14:creationId xmlns:p14="http://schemas.microsoft.com/office/powerpoint/2010/main" val="4294387207"/>
+      </p:ext>
+    </p:extLst>
+  </p:cSld>
+  <p:clrMapOvr>
+    <a:masterClrMapping/>
+  </p:clrMapOvr>
+</p:notes>
 </file>
 
 <file path=ppt/slideLayouts/slideLayout1.xml><?xml version="1.0" encoding="utf-8"?>
@@ -173,10 +971,9 @@
           <a:lstStyle/>
           <a:p>
             <a:r>
-              <a:rPr lang="en-US" smtClean="0"/>
+              <a:rPr lang="en-US"/>
               <a:t>Click to edit Master title style</a:t>
             </a:r>
-            <a:endParaRPr lang="en-US"/>
           </a:p>
         </p:txBody>
       </p:sp>
@@ -292,10 +1089,9 @@
           </a:lstStyle>
           <a:p>
             <a:r>
-              <a:rPr lang="en-US" smtClean="0"/>
+              <a:rPr lang="en-US"/>
               <a:t>Click to edit Master subtitle style</a:t>
             </a:r>
-            <a:endParaRPr lang="en-US"/>
           </a:p>
         </p:txBody>
       </p:sp>
@@ -316,7 +1112,7 @@
           <a:p>
             <a:fld id="{5BCAD085-E8A6-8845-BD4E-CB4CCA059FC4}" type="datetimeFigureOut">
               <a:rPr lang="en-US" smtClean="0"/>
-              <a:t>1/27/13</a:t>
+              <a:t>5/13/2026</a:t>
             </a:fld>
             <a:endParaRPr lang="en-US"/>
           </a:p>
@@ -410,10 +1206,9 @@
           <a:lstStyle/>
           <a:p>
             <a:r>
-              <a:rPr lang="en-US" smtClean="0"/>
+              <a:rPr lang="en-US"/>
               <a:t>Click to edit Master title style</a:t>
             </a:r>
-            <a:endParaRPr lang="en-US"/>
           </a:p>
         </p:txBody>
       </p:sp>
@@ -434,38 +1229,37 @@
           <a:p>
             <a:pPr lvl="0"/>
             <a:r>
-              <a:rPr lang="en-US" smtClean="0"/>
+              <a:rPr lang="en-US"/>
               <a:t>Click to edit Master text styles</a:t>
             </a:r>
           </a:p>
           <a:p>
             <a:pPr lvl="1"/>
             <a:r>
-              <a:rPr lang="en-US" smtClean="0"/>
+              <a:rPr lang="en-US"/>
               <a:t>Second level</a:t>
             </a:r>
           </a:p>
           <a:p>
             <a:pPr lvl="2"/>
             <a:r>
-              <a:rPr lang="en-US" smtClean="0"/>
+              <a:rPr lang="en-US"/>
               <a:t>Third level</a:t>
             </a:r>
           </a:p>
           <a:p>
             <a:pPr lvl="3"/>
             <a:r>
-              <a:rPr lang="en-US" smtClean="0"/>
+              <a:rPr lang="en-US"/>
               <a:t>Fourth level</a:t>
             </a:r>
           </a:p>
           <a:p>
             <a:pPr lvl="4"/>
             <a:r>
-              <a:rPr lang="en-US" smtClean="0"/>
+              <a:rPr lang="en-US"/>
               <a:t>Fifth level</a:t>
             </a:r>
-            <a:endParaRPr lang="en-US"/>
           </a:p>
         </p:txBody>
       </p:sp>
@@ -486,7 +1280,7 @@
           <a:p>
             <a:fld id="{5BCAD085-E8A6-8845-BD4E-CB4CCA059FC4}" type="datetimeFigureOut">
               <a:rPr lang="en-US" smtClean="0"/>
-              <a:t>1/27/13</a:t>
+              <a:t>5/13/2026</a:t>
             </a:fld>
             <a:endParaRPr lang="en-US"/>
           </a:p>
@@ -585,10 +1379,9 @@
           <a:lstStyle/>
           <a:p>
             <a:r>
-              <a:rPr lang="en-US" smtClean="0"/>
+              <a:rPr lang="en-US"/>
               <a:t>Click to edit Master title style</a:t>
             </a:r>
-            <a:endParaRPr lang="en-US"/>
           </a:p>
         </p:txBody>
       </p:sp>
@@ -614,38 +1407,37 @@
           <a:p>
             <a:pPr lvl="0"/>
             <a:r>
-              <a:rPr lang="en-US" smtClean="0"/>
+              <a:rPr lang="en-US"/>
               <a:t>Click to edit Master text styles</a:t>
             </a:r>
           </a:p>
           <a:p>
             <a:pPr lvl="1"/>
             <a:r>
-              <a:rPr lang="en-US" smtClean="0"/>
+              <a:rPr lang="en-US"/>
               <a:t>Second level</a:t>
             </a:r>
           </a:p>
           <a:p>
             <a:pPr lvl="2"/>
             <a:r>
-              <a:rPr lang="en-US" smtClean="0"/>
+              <a:rPr lang="en-US"/>
               <a:t>Third level</a:t>
             </a:r>
           </a:p>
           <a:p>
             <a:pPr lvl="3"/>
             <a:r>
-              <a:rPr lang="en-US" smtClean="0"/>
+              <a:rPr lang="en-US"/>
               <a:t>Fourth level</a:t>
             </a:r>
           </a:p>
           <a:p>
             <a:pPr lvl="4"/>
             <a:r>
-              <a:rPr lang="en-US" smtClean="0"/>
+              <a:rPr lang="en-US"/>
               <a:t>Fifth level</a:t>
             </a:r>
-            <a:endParaRPr lang="en-US"/>
           </a:p>
         </p:txBody>
       </p:sp>
@@ -666,7 +1458,7 @@
           <a:p>
             <a:fld id="{5BCAD085-E8A6-8845-BD4E-CB4CCA059FC4}" type="datetimeFigureOut">
               <a:rPr lang="en-US" smtClean="0"/>
-              <a:t>1/27/13</a:t>
+              <a:t>5/13/2026</a:t>
             </a:fld>
             <a:endParaRPr lang="en-US"/>
           </a:p>
@@ -760,10 +1552,9 @@
           <a:lstStyle/>
           <a:p>
             <a:r>
-              <a:rPr lang="en-US" smtClean="0"/>
+              <a:rPr lang="en-US"/>
               <a:t>Click to edit Master title style</a:t>
             </a:r>
-            <a:endParaRPr lang="en-US"/>
           </a:p>
         </p:txBody>
       </p:sp>
@@ -784,38 +1575,37 @@
           <a:p>
             <a:pPr lvl="0"/>
             <a:r>
-              <a:rPr lang="en-US" smtClean="0"/>
+              <a:rPr lang="en-US"/>
               <a:t>Click to edit Master text styles</a:t>
             </a:r>
           </a:p>
           <a:p>
             <a:pPr lvl="1"/>
             <a:r>
-              <a:rPr lang="en-US" smtClean="0"/>
+              <a:rPr lang="en-US"/>
               <a:t>Second level</a:t>
             </a:r>
           </a:p>
           <a:p>
             <a:pPr lvl="2"/>
             <a:r>
-              <a:rPr lang="en-US" smtClean="0"/>
+              <a:rPr lang="en-US"/>
               <a:t>Third level</a:t>
             </a:r>
           </a:p>
           <a:p>
             <a:pPr lvl="3"/>
             <a:r>
-              <a:rPr lang="en-US" smtClean="0"/>
+              <a:rPr lang="en-US"/>
               <a:t>Fourth level</a:t>
             </a:r>
           </a:p>
           <a:p>
             <a:pPr lvl="4"/>
             <a:r>
-              <a:rPr lang="en-US" smtClean="0"/>
+              <a:rPr lang="en-US"/>
               <a:t>Fifth level</a:t>
             </a:r>
-            <a:endParaRPr lang="en-US"/>
           </a:p>
         </p:txBody>
       </p:sp>
@@ -836,7 +1626,7 @@
           <a:p>
             <a:fld id="{5BCAD085-E8A6-8845-BD4E-CB4CCA059FC4}" type="datetimeFigureOut">
               <a:rPr lang="en-US" smtClean="0"/>
-              <a:t>1/27/13</a:t>
+              <a:t>5/13/2026</a:t>
             </a:fld>
             <a:endParaRPr lang="en-US"/>
           </a:p>
@@ -939,10 +1729,9 @@
           </a:lstStyle>
           <a:p>
             <a:r>
-              <a:rPr lang="en-US" smtClean="0"/>
+              <a:rPr lang="en-US"/>
               <a:t>Click to edit Master title style</a:t>
             </a:r>
-            <a:endParaRPr lang="en-US"/>
           </a:p>
         </p:txBody>
       </p:sp>
@@ -1059,7 +1848,7 @@
           <a:p>
             <a:pPr lvl="0"/>
             <a:r>
-              <a:rPr lang="en-US" smtClean="0"/>
+              <a:rPr lang="en-US"/>
               <a:t>Click to edit Master text styles</a:t>
             </a:r>
           </a:p>
@@ -1082,7 +1871,7 @@
           <a:p>
             <a:fld id="{5BCAD085-E8A6-8845-BD4E-CB4CCA059FC4}" type="datetimeFigureOut">
               <a:rPr lang="en-US" smtClean="0"/>
-              <a:t>1/27/13</a:t>
+              <a:t>5/13/2026</a:t>
             </a:fld>
             <a:endParaRPr lang="en-US"/>
           </a:p>
@@ -1176,10 +1965,9 @@
           <a:lstStyle/>
           <a:p>
             <a:r>
-              <a:rPr lang="en-US" smtClean="0"/>
+              <a:rPr lang="en-US"/>
               <a:t>Click to edit Master title style</a:t>
             </a:r>
-            <a:endParaRPr lang="en-US"/>
           </a:p>
         </p:txBody>
       </p:sp>
@@ -1233,38 +2021,37 @@
           <a:p>
             <a:pPr lvl="0"/>
             <a:r>
-              <a:rPr lang="en-US" smtClean="0"/>
+              <a:rPr lang="en-US"/>
               <a:t>Click to edit Master text styles</a:t>
             </a:r>
           </a:p>
           <a:p>
             <a:pPr lvl="1"/>
             <a:r>
-              <a:rPr lang="en-US" smtClean="0"/>
+              <a:rPr lang="en-US"/>
               <a:t>Second level</a:t>
             </a:r>
           </a:p>
           <a:p>
             <a:pPr lvl="2"/>
             <a:r>
-              <a:rPr lang="en-US" smtClean="0"/>
+              <a:rPr lang="en-US"/>
               <a:t>Third level</a:t>
             </a:r>
           </a:p>
           <a:p>
             <a:pPr lvl="3"/>
             <a:r>
-              <a:rPr lang="en-US" smtClean="0"/>
+              <a:rPr lang="en-US"/>
               <a:t>Fourth level</a:t>
             </a:r>
           </a:p>
           <a:p>
             <a:pPr lvl="4"/>
             <a:r>
-              <a:rPr lang="en-US" smtClean="0"/>
+              <a:rPr lang="en-US"/>
               <a:t>Fifth level</a:t>
             </a:r>
-            <a:endParaRPr lang="en-US"/>
           </a:p>
         </p:txBody>
       </p:sp>
@@ -1318,38 +2105,37 @@
           <a:p>
             <a:pPr lvl="0"/>
             <a:r>
-              <a:rPr lang="en-US" smtClean="0"/>
+              <a:rPr lang="en-US"/>
               <a:t>Click to edit Master text styles</a:t>
             </a:r>
           </a:p>
           <a:p>
             <a:pPr lvl="1"/>
             <a:r>
-              <a:rPr lang="en-US" smtClean="0"/>
+              <a:rPr lang="en-US"/>
               <a:t>Second level</a:t>
             </a:r>
           </a:p>
           <a:p>
             <a:pPr lvl="2"/>
             <a:r>
-              <a:rPr lang="en-US" smtClean="0"/>
+              <a:rPr lang="en-US"/>
               <a:t>Third level</a:t>
             </a:r>
           </a:p>
           <a:p>
             <a:pPr lvl="3"/>
             <a:r>
-              <a:rPr lang="en-US" smtClean="0"/>
+              <a:rPr lang="en-US"/>
               <a:t>Fourth level</a:t>
             </a:r>
           </a:p>
           <a:p>
             <a:pPr lvl="4"/>
             <a:r>
-              <a:rPr lang="en-US" smtClean="0"/>
+              <a:rPr lang="en-US"/>
               <a:t>Fifth level</a:t>
             </a:r>
-            <a:endParaRPr lang="en-US"/>
           </a:p>
         </p:txBody>
       </p:sp>
@@ -1370,7 +2156,7 @@
           <a:p>
             <a:fld id="{5BCAD085-E8A6-8845-BD4E-CB4CCA059FC4}" type="datetimeFigureOut">
               <a:rPr lang="en-US" smtClean="0"/>
-              <a:t>1/27/13</a:t>
+              <a:t>5/13/2026</a:t>
             </a:fld>
             <a:endParaRPr lang="en-US"/>
           </a:p>
@@ -1468,10 +2254,9 @@
           </a:lstStyle>
           <a:p>
             <a:r>
-              <a:rPr lang="en-US" smtClean="0"/>
+              <a:rPr lang="en-US"/>
               <a:t>Click to edit Master title style</a:t>
             </a:r>
-            <a:endParaRPr lang="en-US"/>
           </a:p>
         </p:txBody>
       </p:sp>
@@ -1534,7 +2319,7 @@
           <a:p>
             <a:pPr lvl="0"/>
             <a:r>
-              <a:rPr lang="en-US" smtClean="0"/>
+              <a:rPr lang="en-US"/>
               <a:t>Click to edit Master text styles</a:t>
             </a:r>
           </a:p>
@@ -1590,38 +2375,37 @@
           <a:p>
             <a:pPr lvl="0"/>
             <a:r>
-              <a:rPr lang="en-US" smtClean="0"/>
+              <a:rPr lang="en-US"/>
               <a:t>Click to edit Master text styles</a:t>
             </a:r>
           </a:p>
           <a:p>
             <a:pPr lvl="1"/>
             <a:r>
-              <a:rPr lang="en-US" smtClean="0"/>
+              <a:rPr lang="en-US"/>
               <a:t>Second level</a:t>
             </a:r>
           </a:p>
           <a:p>
             <a:pPr lvl="2"/>
             <a:r>
-              <a:rPr lang="en-US" smtClean="0"/>
+              <a:rPr lang="en-US"/>
               <a:t>Third level</a:t>
             </a:r>
           </a:p>
           <a:p>
             <a:pPr lvl="3"/>
             <a:r>
-              <a:rPr lang="en-US" smtClean="0"/>
+              <a:rPr lang="en-US"/>
               <a:t>Fourth level</a:t>
             </a:r>
           </a:p>
           <a:p>
             <a:pPr lvl="4"/>
             <a:r>
-              <a:rPr lang="en-US" smtClean="0"/>
+              <a:rPr lang="en-US"/>
               <a:t>Fifth level</a:t>
             </a:r>
-            <a:endParaRPr lang="en-US"/>
           </a:p>
         </p:txBody>
       </p:sp>
@@ -1684,7 +2468,7 @@
           <a:p>
             <a:pPr lvl="0"/>
             <a:r>
-              <a:rPr lang="en-US" smtClean="0"/>
+              <a:rPr lang="en-US"/>
               <a:t>Click to edit Master text styles</a:t>
             </a:r>
           </a:p>
@@ -1740,38 +2524,37 @@
           <a:p>
             <a:pPr lvl="0"/>
             <a:r>
-              <a:rPr lang="en-US" smtClean="0"/>
+              <a:rPr lang="en-US"/>
               <a:t>Click to edit Master text styles</a:t>
             </a:r>
           </a:p>
           <a:p>
             <a:pPr lvl="1"/>
             <a:r>
-              <a:rPr lang="en-US" smtClean="0"/>
+              <a:rPr lang="en-US"/>
               <a:t>Second level</a:t>
             </a:r>
           </a:p>
           <a:p>
             <a:pPr lvl="2"/>
             <a:r>
-              <a:rPr lang="en-US" smtClean="0"/>
+              <a:rPr lang="en-US"/>
               <a:t>Third level</a:t>
             </a:r>
           </a:p>
           <a:p>
             <a:pPr lvl="3"/>
             <a:r>
-              <a:rPr lang="en-US" smtClean="0"/>
+              <a:rPr lang="en-US"/>
               <a:t>Fourth level</a:t>
             </a:r>
           </a:p>
           <a:p>
             <a:pPr lvl="4"/>
             <a:r>
-              <a:rPr lang="en-US" smtClean="0"/>
+              <a:rPr lang="en-US"/>
               <a:t>Fifth level</a:t>
             </a:r>
-            <a:endParaRPr lang="en-US"/>
           </a:p>
         </p:txBody>
       </p:sp>
@@ -1792,7 +2575,7 @@
           <a:p>
             <a:fld id="{5BCAD085-E8A6-8845-BD4E-CB4CCA059FC4}" type="datetimeFigureOut">
               <a:rPr lang="en-US" smtClean="0"/>
-              <a:t>1/27/13</a:t>
+              <a:t>5/13/2026</a:t>
             </a:fld>
             <a:endParaRPr lang="en-US"/>
           </a:p>
@@ -1886,10 +2669,9 @@
           <a:lstStyle/>
           <a:p>
             <a:r>
-              <a:rPr lang="en-US" smtClean="0"/>
+              <a:rPr lang="en-US"/>
               <a:t>Click to edit Master title style</a:t>
             </a:r>
-            <a:endParaRPr lang="en-US"/>
           </a:p>
         </p:txBody>
       </p:sp>
@@ -1910,7 +2692,7 @@
           <a:p>
             <a:fld id="{5BCAD085-E8A6-8845-BD4E-CB4CCA059FC4}" type="datetimeFigureOut">
               <a:rPr lang="en-US" smtClean="0"/>
-              <a:t>1/27/13</a:t>
+              <a:t>5/13/2026</a:t>
             </a:fld>
             <a:endParaRPr lang="en-US"/>
           </a:p>
@@ -2005,7 +2787,7 @@
           <a:p>
             <a:fld id="{5BCAD085-E8A6-8845-BD4E-CB4CCA059FC4}" type="datetimeFigureOut">
               <a:rPr lang="en-US" smtClean="0"/>
-              <a:t>1/27/13</a:t>
+              <a:t>5/13/2026</a:t>
             </a:fld>
             <a:endParaRPr lang="en-US"/>
           </a:p>
@@ -2108,10 +2890,9 @@
           </a:lstStyle>
           <a:p>
             <a:r>
-              <a:rPr lang="en-US" smtClean="0"/>
+              <a:rPr lang="en-US"/>
               <a:t>Click to edit Master title style</a:t>
             </a:r>
-            <a:endParaRPr lang="en-US"/>
           </a:p>
         </p:txBody>
       </p:sp>
@@ -2165,38 +2946,37 @@
           <a:p>
             <a:pPr lvl="0"/>
             <a:r>
-              <a:rPr lang="en-US" smtClean="0"/>
+              <a:rPr lang="en-US"/>
               <a:t>Click to edit Master text styles</a:t>
             </a:r>
           </a:p>
           <a:p>
             <a:pPr lvl="1"/>
             <a:r>
-              <a:rPr lang="en-US" smtClean="0"/>
+              <a:rPr lang="en-US"/>
               <a:t>Second level</a:t>
             </a:r>
           </a:p>
           <a:p>
             <a:pPr lvl="2"/>
             <a:r>
-              <a:rPr lang="en-US" smtClean="0"/>
+              <a:rPr lang="en-US"/>
               <a:t>Third level</a:t>
             </a:r>
           </a:p>
           <a:p>
             <a:pPr lvl="3"/>
             <a:r>
-              <a:rPr lang="en-US" smtClean="0"/>
+              <a:rPr lang="en-US"/>
               <a:t>Fourth level</a:t>
             </a:r>
           </a:p>
           <a:p>
             <a:pPr lvl="4"/>
             <a:r>
-              <a:rPr lang="en-US" smtClean="0"/>
+              <a:rPr lang="en-US"/>
               <a:t>Fifth level</a:t>
             </a:r>
-            <a:endParaRPr lang="en-US"/>
           </a:p>
         </p:txBody>
       </p:sp>
@@ -2259,7 +3039,7 @@
           <a:p>
             <a:pPr lvl="0"/>
             <a:r>
-              <a:rPr lang="en-US" smtClean="0"/>
+              <a:rPr lang="en-US"/>
               <a:t>Click to edit Master text styles</a:t>
             </a:r>
           </a:p>
@@ -2282,7 +3062,7 @@
           <a:p>
             <a:fld id="{5BCAD085-E8A6-8845-BD4E-CB4CCA059FC4}" type="datetimeFigureOut">
               <a:rPr lang="en-US" smtClean="0"/>
-              <a:t>1/27/13</a:t>
+              <a:t>5/13/2026</a:t>
             </a:fld>
             <a:endParaRPr lang="en-US"/>
           </a:p>
@@ -2385,10 +3165,9 @@
           </a:lstStyle>
           <a:p>
             <a:r>
-              <a:rPr lang="en-US" smtClean="0"/>
+              <a:rPr lang="en-US"/>
               <a:t>Click to edit Master title style</a:t>
             </a:r>
-            <a:endParaRPr lang="en-US"/>
           </a:p>
         </p:txBody>
       </p:sp>
@@ -2512,7 +3291,7 @@
           <a:p>
             <a:pPr lvl="0"/>
             <a:r>
-              <a:rPr lang="en-US" smtClean="0"/>
+              <a:rPr lang="en-US"/>
               <a:t>Click to edit Master text styles</a:t>
             </a:r>
           </a:p>
@@ -2535,7 +3314,7 @@
           <a:p>
             <a:fld id="{5BCAD085-E8A6-8845-BD4E-CB4CCA059FC4}" type="datetimeFigureOut">
               <a:rPr lang="en-US" smtClean="0"/>
-              <a:t>1/27/13</a:t>
+              <a:t>5/13/2026</a:t>
             </a:fld>
             <a:endParaRPr lang="en-US"/>
           </a:p>
@@ -2644,10 +3423,9 @@
           <a:lstStyle/>
           <a:p>
             <a:r>
-              <a:rPr lang="en-US" smtClean="0"/>
+              <a:rPr lang="en-US"/>
               <a:t>Click to edit Master title style</a:t>
             </a:r>
-            <a:endParaRPr lang="en-US"/>
           </a:p>
         </p:txBody>
       </p:sp>
@@ -2678,38 +3456,37 @@
           <a:p>
             <a:pPr lvl="0"/>
             <a:r>
-              <a:rPr lang="en-US" smtClean="0"/>
+              <a:rPr lang="en-US"/>
               <a:t>Click to edit Master text styles</a:t>
             </a:r>
           </a:p>
           <a:p>
             <a:pPr lvl="1"/>
             <a:r>
-              <a:rPr lang="en-US" smtClean="0"/>
+              <a:rPr lang="en-US"/>
               <a:t>Second level</a:t>
             </a:r>
           </a:p>
           <a:p>
             <a:pPr lvl="2"/>
             <a:r>
-              <a:rPr lang="en-US" smtClean="0"/>
+              <a:rPr lang="en-US"/>
               <a:t>Third level</a:t>
             </a:r>
           </a:p>
           <a:p>
             <a:pPr lvl="3"/>
             <a:r>
-              <a:rPr lang="en-US" smtClean="0"/>
+              <a:rPr lang="en-US"/>
               <a:t>Fourth level</a:t>
             </a:r>
           </a:p>
           <a:p>
             <a:pPr lvl="4"/>
             <a:r>
-              <a:rPr lang="en-US" smtClean="0"/>
+              <a:rPr lang="en-US"/>
               <a:t>Fifth level</a:t>
             </a:r>
-            <a:endParaRPr lang="en-US"/>
           </a:p>
         </p:txBody>
       </p:sp>
@@ -2748,7 +3525,7 @@
           <a:p>
             <a:fld id="{5BCAD085-E8A6-8845-BD4E-CB4CCA059FC4}" type="datetimeFigureOut">
               <a:rPr lang="en-US" smtClean="0"/>
-              <a:t>1/27/13</a:t>
+              <a:t>5/13/2026</a:t>
             </a:fld>
             <a:endParaRPr lang="en-US"/>
           </a:p>
@@ -3107,7 +3884,7 @@
 </file>
 
 <file path=ppt/slides/slide1.xml><?xml version="1.0" encoding="utf-8"?>
-<p:sld xmlns:a="http://schemas.openxmlformats.org/drawingml/2006/main" xmlns:p="http://schemas.openxmlformats.org/presentationml/2006/main" xmlns:r="http://schemas.openxmlformats.org/officeDocument/2006/relationships">
+<p:sld xmlns:a="http://schemas.openxmlformats.org/drawingml/2006/main" xmlns:r="http://schemas.openxmlformats.org/officeDocument/2006/relationships" xmlns:p="http://schemas.openxmlformats.org/presentationml/2006/main">
   <p:cSld>
     <p:spTree>
       <p:nvGrpSpPr>
@@ -3115,7 +3892,14 @@
         <p:cNvGrpSpPr/>
         <p:nvPr/>
       </p:nvGrpSpPr>
-      <p:grpSpPr/>
+      <p:grpSpPr>
+        <a:xfrm>
+          <a:off x="0" y="0"/>
+          <a:ext cx="0" cy="0"/>
+          <a:chOff x="0" y="0"/>
+          <a:chExt cx="0" cy="0"/>
+        </a:xfrm>
+      </p:grpSpPr>
       <p:pic>
         <p:nvPicPr>
           <p:cNvPr id="2" name="Picture 1" descr="page-01.png"/>
@@ -3149,7 +3933,7 @@
 </file>
 
 <file path=ppt/slides/slide10.xml><?xml version="1.0" encoding="utf-8"?>
-<p:sld xmlns:a="http://schemas.openxmlformats.org/drawingml/2006/main" xmlns:p="http://schemas.openxmlformats.org/presentationml/2006/main" xmlns:r="http://schemas.openxmlformats.org/officeDocument/2006/relationships">
+<p:sld xmlns:a="http://schemas.openxmlformats.org/drawingml/2006/main" xmlns:r="http://schemas.openxmlformats.org/officeDocument/2006/relationships" xmlns:p="http://schemas.openxmlformats.org/presentationml/2006/main">
   <p:cSld>
     <p:spTree>
       <p:nvGrpSpPr>
@@ -3157,7 +3941,14 @@
         <p:cNvGrpSpPr/>
         <p:nvPr/>
       </p:nvGrpSpPr>
-      <p:grpSpPr/>
+      <p:grpSpPr>
+        <a:xfrm>
+          <a:off x="0" y="0"/>
+          <a:ext cx="0" cy="0"/>
+          <a:chOff x="0" y="0"/>
+          <a:chExt cx="0" cy="0"/>
+        </a:xfrm>
+      </p:grpSpPr>
       <p:pic>
         <p:nvPicPr>
           <p:cNvPr id="2" name="Picture 1" descr="page-10.png"/>
@@ -3191,7 +3982,7 @@
 </file>
 
 <file path=ppt/slides/slide11.xml><?xml version="1.0" encoding="utf-8"?>
-<p:sld xmlns:a="http://schemas.openxmlformats.org/drawingml/2006/main" xmlns:p="http://schemas.openxmlformats.org/presentationml/2006/main" xmlns:r="http://schemas.openxmlformats.org/officeDocument/2006/relationships">
+<p:sld xmlns:a="http://schemas.openxmlformats.org/drawingml/2006/main" xmlns:r="http://schemas.openxmlformats.org/officeDocument/2006/relationships" xmlns:p="http://schemas.openxmlformats.org/presentationml/2006/main">
   <p:cSld>
     <p:spTree>
       <p:nvGrpSpPr>
@@ -3199,7 +3990,14 @@
         <p:cNvGrpSpPr/>
         <p:nvPr/>
       </p:nvGrpSpPr>
-      <p:grpSpPr/>
+      <p:grpSpPr>
+        <a:xfrm>
+          <a:off x="0" y="0"/>
+          <a:ext cx="0" cy="0"/>
+          <a:chOff x="0" y="0"/>
+          <a:chExt cx="0" cy="0"/>
+        </a:xfrm>
+      </p:grpSpPr>
       <p:pic>
         <p:nvPicPr>
           <p:cNvPr id="2" name="Picture 1" descr="page-11.png"/>
@@ -3233,7 +4031,7 @@
 </file>
 
 <file path=ppt/slides/slide12.xml><?xml version="1.0" encoding="utf-8"?>
-<p:sld xmlns:a="http://schemas.openxmlformats.org/drawingml/2006/main" xmlns:p="http://schemas.openxmlformats.org/presentationml/2006/main" xmlns:r="http://schemas.openxmlformats.org/officeDocument/2006/relationships">
+<p:sld xmlns:a="http://schemas.openxmlformats.org/drawingml/2006/main" xmlns:r="http://schemas.openxmlformats.org/officeDocument/2006/relationships" xmlns:p="http://schemas.openxmlformats.org/presentationml/2006/main">
   <p:cSld>
     <p:spTree>
       <p:nvGrpSpPr>
@@ -3241,7 +4039,14 @@
         <p:cNvGrpSpPr/>
         <p:nvPr/>
       </p:nvGrpSpPr>
-      <p:grpSpPr/>
+      <p:grpSpPr>
+        <a:xfrm>
+          <a:off x="0" y="0"/>
+          <a:ext cx="0" cy="0"/>
+          <a:chOff x="0" y="0"/>
+          <a:chExt cx="0" cy="0"/>
+        </a:xfrm>
+      </p:grpSpPr>
       <p:pic>
         <p:nvPicPr>
           <p:cNvPr id="2" name="Picture 1" descr="page-12.png"/>
@@ -3275,7 +4080,7 @@
 </file>
 
 <file path=ppt/slides/slide13.xml><?xml version="1.0" encoding="utf-8"?>
-<p:sld xmlns:a="http://schemas.openxmlformats.org/drawingml/2006/main" xmlns:p="http://schemas.openxmlformats.org/presentationml/2006/main" xmlns:r="http://schemas.openxmlformats.org/officeDocument/2006/relationships">
+<p:sld xmlns:a="http://schemas.openxmlformats.org/drawingml/2006/main" xmlns:r="http://schemas.openxmlformats.org/officeDocument/2006/relationships" xmlns:p="http://schemas.openxmlformats.org/presentationml/2006/main">
   <p:cSld>
     <p:spTree>
       <p:nvGrpSpPr>
@@ -3283,7 +4088,14 @@
         <p:cNvGrpSpPr/>
         <p:nvPr/>
       </p:nvGrpSpPr>
-      <p:grpSpPr/>
+      <p:grpSpPr>
+        <a:xfrm>
+          <a:off x="0" y="0"/>
+          <a:ext cx="0" cy="0"/>
+          <a:chOff x="0" y="0"/>
+          <a:chExt cx="0" cy="0"/>
+        </a:xfrm>
+      </p:grpSpPr>
       <p:pic>
         <p:nvPicPr>
           <p:cNvPr id="2" name="Picture 1" descr="page-13.png"/>
@@ -3317,7 +4129,7 @@
 </file>
 
 <file path=ppt/slides/slide14.xml><?xml version="1.0" encoding="utf-8"?>
-<p:sld xmlns:a="http://schemas.openxmlformats.org/drawingml/2006/main" xmlns:p="http://schemas.openxmlformats.org/presentationml/2006/main" xmlns:r="http://schemas.openxmlformats.org/officeDocument/2006/relationships">
+<p:sld xmlns:a="http://schemas.openxmlformats.org/drawingml/2006/main" xmlns:r="http://schemas.openxmlformats.org/officeDocument/2006/relationships" xmlns:p="http://schemas.openxmlformats.org/presentationml/2006/main">
   <p:cSld>
     <p:spTree>
       <p:nvGrpSpPr>
@@ -3325,7 +4137,14 @@
         <p:cNvGrpSpPr/>
         <p:nvPr/>
       </p:nvGrpSpPr>
-      <p:grpSpPr/>
+      <p:grpSpPr>
+        <a:xfrm>
+          <a:off x="0" y="0"/>
+          <a:ext cx="0" cy="0"/>
+          <a:chOff x="0" y="0"/>
+          <a:chExt cx="0" cy="0"/>
+        </a:xfrm>
+      </p:grpSpPr>
       <p:pic>
         <p:nvPicPr>
           <p:cNvPr id="2" name="Picture 1" descr="page-14.png"/>
@@ -3359,7 +4178,7 @@
 </file>
 
 <file path=ppt/slides/slide15.xml><?xml version="1.0" encoding="utf-8"?>
-<p:sld xmlns:a="http://schemas.openxmlformats.org/drawingml/2006/main" xmlns:p="http://schemas.openxmlformats.org/presentationml/2006/main" xmlns:r="http://schemas.openxmlformats.org/officeDocument/2006/relationships">
+<p:sld xmlns:a="http://schemas.openxmlformats.org/drawingml/2006/main" xmlns:r="http://schemas.openxmlformats.org/officeDocument/2006/relationships" xmlns:p="http://schemas.openxmlformats.org/presentationml/2006/main">
   <p:cSld>
     <p:spTree>
       <p:nvGrpSpPr>
@@ -3367,7 +4186,14 @@
         <p:cNvGrpSpPr/>
         <p:nvPr/>
       </p:nvGrpSpPr>
-      <p:grpSpPr/>
+      <p:grpSpPr>
+        <a:xfrm>
+          <a:off x="0" y="0"/>
+          <a:ext cx="0" cy="0"/>
+          <a:chOff x="0" y="0"/>
+          <a:chExt cx="0" cy="0"/>
+        </a:xfrm>
+      </p:grpSpPr>
       <p:pic>
         <p:nvPicPr>
           <p:cNvPr id="2" name="Picture 1" descr="page-15.png"/>
@@ -3401,7 +4227,7 @@
 </file>
 
 <file path=ppt/slides/slide16.xml><?xml version="1.0" encoding="utf-8"?>
-<p:sld xmlns:a="http://schemas.openxmlformats.org/drawingml/2006/main" xmlns:p="http://schemas.openxmlformats.org/presentationml/2006/main" xmlns:r="http://schemas.openxmlformats.org/officeDocument/2006/relationships">
+<p:sld xmlns:a="http://schemas.openxmlformats.org/drawingml/2006/main" xmlns:r="http://schemas.openxmlformats.org/officeDocument/2006/relationships" xmlns:p="http://schemas.openxmlformats.org/presentationml/2006/main">
   <p:cSld>
     <p:spTree>
       <p:nvGrpSpPr>
@@ -3409,7 +4235,14 @@
         <p:cNvGrpSpPr/>
         <p:nvPr/>
       </p:nvGrpSpPr>
-      <p:grpSpPr/>
+      <p:grpSpPr>
+        <a:xfrm>
+          <a:off x="0" y="0"/>
+          <a:ext cx="0" cy="0"/>
+          <a:chOff x="0" y="0"/>
+          <a:chExt cx="0" cy="0"/>
+        </a:xfrm>
+      </p:grpSpPr>
       <p:pic>
         <p:nvPicPr>
           <p:cNvPr id="2" name="Picture 1" descr="page-16.png"/>
@@ -3419,7 +4252,7 @@
           <p:nvPr/>
         </p:nvPicPr>
         <p:blipFill>
-          <a:blip r:embed="rId2"/>
+          <a:blip r:embed="rId3"/>
           <a:stretch>
             <a:fillRect/>
           </a:stretch>
@@ -3443,7 +4276,7 @@
 </file>
 
 <file path=ppt/slides/slide17.xml><?xml version="1.0" encoding="utf-8"?>
-<p:sld xmlns:a="http://schemas.openxmlformats.org/drawingml/2006/main" xmlns:p="http://schemas.openxmlformats.org/presentationml/2006/main" xmlns:r="http://schemas.openxmlformats.org/officeDocument/2006/relationships">
+<p:sld xmlns:a="http://schemas.openxmlformats.org/drawingml/2006/main" xmlns:r="http://schemas.openxmlformats.org/officeDocument/2006/relationships" xmlns:p="http://schemas.openxmlformats.org/presentationml/2006/main">
   <p:cSld>
     <p:spTree>
       <p:nvGrpSpPr>
@@ -3451,7 +4284,14 @@
         <p:cNvGrpSpPr/>
         <p:nvPr/>
       </p:nvGrpSpPr>
-      <p:grpSpPr/>
+      <p:grpSpPr>
+        <a:xfrm>
+          <a:off x="0" y="0"/>
+          <a:ext cx="0" cy="0"/>
+          <a:chOff x="0" y="0"/>
+          <a:chExt cx="0" cy="0"/>
+        </a:xfrm>
+      </p:grpSpPr>
       <p:pic>
         <p:nvPicPr>
           <p:cNvPr id="2" name="Picture 1" descr="page-17.png"/>
@@ -3461,7 +4301,7 @@
           <p:nvPr/>
         </p:nvPicPr>
         <p:blipFill>
-          <a:blip r:embed="rId2"/>
+          <a:blip r:embed="rId3"/>
           <a:stretch>
             <a:fillRect/>
           </a:stretch>
@@ -3485,7 +4325,7 @@
 </file>
 
 <file path=ppt/slides/slide18.xml><?xml version="1.0" encoding="utf-8"?>
-<p:sld xmlns:a="http://schemas.openxmlformats.org/drawingml/2006/main" xmlns:p="http://schemas.openxmlformats.org/presentationml/2006/main" xmlns:r="http://schemas.openxmlformats.org/officeDocument/2006/relationships">
+<p:sld xmlns:a="http://schemas.openxmlformats.org/drawingml/2006/main" xmlns:r="http://schemas.openxmlformats.org/officeDocument/2006/relationships" xmlns:p="http://schemas.openxmlformats.org/presentationml/2006/main">
   <p:cSld>
     <p:spTree>
       <p:nvGrpSpPr>
@@ -3493,7 +4333,14 @@
         <p:cNvGrpSpPr/>
         <p:nvPr/>
       </p:nvGrpSpPr>
-      <p:grpSpPr/>
+      <p:grpSpPr>
+        <a:xfrm>
+          <a:off x="0" y="0"/>
+          <a:ext cx="0" cy="0"/>
+          <a:chOff x="0" y="0"/>
+          <a:chExt cx="0" cy="0"/>
+        </a:xfrm>
+      </p:grpSpPr>
       <p:pic>
         <p:nvPicPr>
           <p:cNvPr id="2" name="Picture 1" descr="page-18.png"/>
@@ -3503,7 +4350,7 @@
           <p:nvPr/>
         </p:nvPicPr>
         <p:blipFill>
-          <a:blip r:embed="rId2"/>
+          <a:blip r:embed="rId3"/>
           <a:stretch>
             <a:fillRect/>
           </a:stretch>
@@ -3527,7 +4374,7 @@
 </file>
 
 <file path=ppt/slides/slide19.xml><?xml version="1.0" encoding="utf-8"?>
-<p:sld xmlns:a="http://schemas.openxmlformats.org/drawingml/2006/main" xmlns:p="http://schemas.openxmlformats.org/presentationml/2006/main" xmlns:r="http://schemas.openxmlformats.org/officeDocument/2006/relationships">
+<p:sld xmlns:a="http://schemas.openxmlformats.org/drawingml/2006/main" xmlns:r="http://schemas.openxmlformats.org/officeDocument/2006/relationships" xmlns:p="http://schemas.openxmlformats.org/presentationml/2006/main">
   <p:cSld>
     <p:spTree>
       <p:nvGrpSpPr>
@@ -3535,7 +4382,14 @@
         <p:cNvGrpSpPr/>
         <p:nvPr/>
       </p:nvGrpSpPr>
-      <p:grpSpPr/>
+      <p:grpSpPr>
+        <a:xfrm>
+          <a:off x="0" y="0"/>
+          <a:ext cx="0" cy="0"/>
+          <a:chOff x="0" y="0"/>
+          <a:chExt cx="0" cy="0"/>
+        </a:xfrm>
+      </p:grpSpPr>
       <p:pic>
         <p:nvPicPr>
           <p:cNvPr id="2" name="Picture 1" descr="page-19.png"/>
@@ -3545,7 +4399,7 @@
           <p:nvPr/>
         </p:nvPicPr>
         <p:blipFill>
-          <a:blip r:embed="rId2"/>
+          <a:blip r:embed="rId3"/>
           <a:stretch>
             <a:fillRect/>
           </a:stretch>
@@ -3569,7 +4423,7 @@
 </file>
 
 <file path=ppt/slides/slide2.xml><?xml version="1.0" encoding="utf-8"?>
-<p:sld xmlns:a="http://schemas.openxmlformats.org/drawingml/2006/main" xmlns:p="http://schemas.openxmlformats.org/presentationml/2006/main" xmlns:r="http://schemas.openxmlformats.org/officeDocument/2006/relationships">
+<p:sld xmlns:a="http://schemas.openxmlformats.org/drawingml/2006/main" xmlns:r="http://schemas.openxmlformats.org/officeDocument/2006/relationships" xmlns:p="http://schemas.openxmlformats.org/presentationml/2006/main">
   <p:cSld>
     <p:spTree>
       <p:nvGrpSpPr>
@@ -3577,7 +4431,14 @@
         <p:cNvGrpSpPr/>
         <p:nvPr/>
       </p:nvGrpSpPr>
-      <p:grpSpPr/>
+      <p:grpSpPr>
+        <a:xfrm>
+          <a:off x="0" y="0"/>
+          <a:ext cx="0" cy="0"/>
+          <a:chOff x="0" y="0"/>
+          <a:chExt cx="0" cy="0"/>
+        </a:xfrm>
+      </p:grpSpPr>
       <p:pic>
         <p:nvPicPr>
           <p:cNvPr id="2" name="Picture 1" descr="page-02.png"/>
@@ -3611,7 +4472,7 @@
 </file>
 
 <file path=ppt/slides/slide20.xml><?xml version="1.0" encoding="utf-8"?>
-<p:sld xmlns:a="http://schemas.openxmlformats.org/drawingml/2006/main" xmlns:p="http://schemas.openxmlformats.org/presentationml/2006/main" xmlns:r="http://schemas.openxmlformats.org/officeDocument/2006/relationships">
+<p:sld xmlns:a="http://schemas.openxmlformats.org/drawingml/2006/main" xmlns:r="http://schemas.openxmlformats.org/officeDocument/2006/relationships" xmlns:p="http://schemas.openxmlformats.org/presentationml/2006/main">
   <p:cSld>
     <p:spTree>
       <p:nvGrpSpPr>
@@ -3619,7 +4480,14 @@
         <p:cNvGrpSpPr/>
         <p:nvPr/>
       </p:nvGrpSpPr>
-      <p:grpSpPr/>
+      <p:grpSpPr>
+        <a:xfrm>
+          <a:off x="0" y="0"/>
+          <a:ext cx="0" cy="0"/>
+          <a:chOff x="0" y="0"/>
+          <a:chExt cx="0" cy="0"/>
+        </a:xfrm>
+      </p:grpSpPr>
       <p:pic>
         <p:nvPicPr>
           <p:cNvPr id="2" name="Picture 1" descr="page-20.png"/>
@@ -3653,7 +4521,7 @@
 </file>
 
 <file path=ppt/slides/slide21.xml><?xml version="1.0" encoding="utf-8"?>
-<p:sld xmlns:a="http://schemas.openxmlformats.org/drawingml/2006/main" xmlns:p="http://schemas.openxmlformats.org/presentationml/2006/main" xmlns:r="http://schemas.openxmlformats.org/officeDocument/2006/relationships">
+<p:sld xmlns:a="http://schemas.openxmlformats.org/drawingml/2006/main" xmlns:r="http://schemas.openxmlformats.org/officeDocument/2006/relationships" xmlns:p="http://schemas.openxmlformats.org/presentationml/2006/main">
   <p:cSld>
     <p:spTree>
       <p:nvGrpSpPr>
@@ -3661,7 +4529,14 @@
         <p:cNvGrpSpPr/>
         <p:nvPr/>
       </p:nvGrpSpPr>
-      <p:grpSpPr/>
+      <p:grpSpPr>
+        <a:xfrm>
+          <a:off x="0" y="0"/>
+          <a:ext cx="0" cy="0"/>
+          <a:chOff x="0" y="0"/>
+          <a:chExt cx="0" cy="0"/>
+        </a:xfrm>
+      </p:grpSpPr>
       <p:pic>
         <p:nvPicPr>
           <p:cNvPr id="2" name="Picture 1" descr="page-21.png"/>
@@ -3695,7 +4570,7 @@
 </file>
 
 <file path=ppt/slides/slide22.xml><?xml version="1.0" encoding="utf-8"?>
-<p:sld xmlns:a="http://schemas.openxmlformats.org/drawingml/2006/main" xmlns:p="http://schemas.openxmlformats.org/presentationml/2006/main" xmlns:r="http://schemas.openxmlformats.org/officeDocument/2006/relationships">
+<p:sld xmlns:a="http://schemas.openxmlformats.org/drawingml/2006/main" xmlns:r="http://schemas.openxmlformats.org/officeDocument/2006/relationships" xmlns:p="http://schemas.openxmlformats.org/presentationml/2006/main">
   <p:cSld>
     <p:spTree>
       <p:nvGrpSpPr>
@@ -3703,7 +4578,14 @@
         <p:cNvGrpSpPr/>
         <p:nvPr/>
       </p:nvGrpSpPr>
-      <p:grpSpPr/>
+      <p:grpSpPr>
+        <a:xfrm>
+          <a:off x="0" y="0"/>
+          <a:ext cx="0" cy="0"/>
+          <a:chOff x="0" y="0"/>
+          <a:chExt cx="0" cy="0"/>
+        </a:xfrm>
+      </p:grpSpPr>
       <p:pic>
         <p:nvPicPr>
           <p:cNvPr id="2" name="Picture 1" descr="page-22.png"/>
@@ -3737,7 +4619,7 @@
 </file>
 
 <file path=ppt/slides/slide23.xml><?xml version="1.0" encoding="utf-8"?>
-<p:sld xmlns:a="http://schemas.openxmlformats.org/drawingml/2006/main" xmlns:p="http://schemas.openxmlformats.org/presentationml/2006/main" xmlns:r="http://schemas.openxmlformats.org/officeDocument/2006/relationships">
+<p:sld xmlns:a="http://schemas.openxmlformats.org/drawingml/2006/main" xmlns:r="http://schemas.openxmlformats.org/officeDocument/2006/relationships" xmlns:p="http://schemas.openxmlformats.org/presentationml/2006/main">
   <p:cSld>
     <p:spTree>
       <p:nvGrpSpPr>
@@ -3745,7 +4627,14 @@
         <p:cNvGrpSpPr/>
         <p:nvPr/>
       </p:nvGrpSpPr>
-      <p:grpSpPr/>
+      <p:grpSpPr>
+        <a:xfrm>
+          <a:off x="0" y="0"/>
+          <a:ext cx="0" cy="0"/>
+          <a:chOff x="0" y="0"/>
+          <a:chExt cx="0" cy="0"/>
+        </a:xfrm>
+      </p:grpSpPr>
       <p:pic>
         <p:nvPicPr>
           <p:cNvPr id="2" name="Picture 1" descr="page-23.png"/>
@@ -3779,7 +4668,7 @@
 </file>
 
 <file path=ppt/slides/slide24.xml><?xml version="1.0" encoding="utf-8"?>
-<p:sld xmlns:a="http://schemas.openxmlformats.org/drawingml/2006/main" xmlns:p="http://schemas.openxmlformats.org/presentationml/2006/main" xmlns:r="http://schemas.openxmlformats.org/officeDocument/2006/relationships">
+<p:sld xmlns:a="http://schemas.openxmlformats.org/drawingml/2006/main" xmlns:r="http://schemas.openxmlformats.org/officeDocument/2006/relationships" xmlns:p="http://schemas.openxmlformats.org/presentationml/2006/main">
   <p:cSld>
     <p:spTree>
       <p:nvGrpSpPr>
@@ -3787,7 +4676,14 @@
         <p:cNvGrpSpPr/>
         <p:nvPr/>
       </p:nvGrpSpPr>
-      <p:grpSpPr/>
+      <p:grpSpPr>
+        <a:xfrm>
+          <a:off x="0" y="0"/>
+          <a:ext cx="0" cy="0"/>
+          <a:chOff x="0" y="0"/>
+          <a:chExt cx="0" cy="0"/>
+        </a:xfrm>
+      </p:grpSpPr>
       <p:pic>
         <p:nvPicPr>
           <p:cNvPr id="2" name="Picture 1" descr="page-24.png"/>
@@ -3821,7 +4717,7 @@
 </file>
 
 <file path=ppt/slides/slide25.xml><?xml version="1.0" encoding="utf-8"?>
-<p:sld xmlns:a="http://schemas.openxmlformats.org/drawingml/2006/main" xmlns:p="http://schemas.openxmlformats.org/presentationml/2006/main" xmlns:r="http://schemas.openxmlformats.org/officeDocument/2006/relationships">
+<p:sld xmlns:a="http://schemas.openxmlformats.org/drawingml/2006/main" xmlns:r="http://schemas.openxmlformats.org/officeDocument/2006/relationships" xmlns:p="http://schemas.openxmlformats.org/presentationml/2006/main">
   <p:cSld>
     <p:spTree>
       <p:nvGrpSpPr>
@@ -3829,7 +4725,14 @@
         <p:cNvGrpSpPr/>
         <p:nvPr/>
       </p:nvGrpSpPr>
-      <p:grpSpPr/>
+      <p:grpSpPr>
+        <a:xfrm>
+          <a:off x="0" y="0"/>
+          <a:ext cx="0" cy="0"/>
+          <a:chOff x="0" y="0"/>
+          <a:chExt cx="0" cy="0"/>
+        </a:xfrm>
+      </p:grpSpPr>
       <p:pic>
         <p:nvPicPr>
           <p:cNvPr id="2" name="Picture 1" descr="page-25.png"/>
@@ -3863,7 +4766,7 @@
 </file>
 
 <file path=ppt/slides/slide26.xml><?xml version="1.0" encoding="utf-8"?>
-<p:sld xmlns:a="http://schemas.openxmlformats.org/drawingml/2006/main" xmlns:p="http://schemas.openxmlformats.org/presentationml/2006/main" xmlns:r="http://schemas.openxmlformats.org/officeDocument/2006/relationships">
+<p:sld xmlns:a="http://schemas.openxmlformats.org/drawingml/2006/main" xmlns:r="http://schemas.openxmlformats.org/officeDocument/2006/relationships" xmlns:p="http://schemas.openxmlformats.org/presentationml/2006/main">
   <p:cSld>
     <p:spTree>
       <p:nvGrpSpPr>
@@ -3871,7 +4774,14 @@
         <p:cNvGrpSpPr/>
         <p:nvPr/>
       </p:nvGrpSpPr>
-      <p:grpSpPr/>
+      <p:grpSpPr>
+        <a:xfrm>
+          <a:off x="0" y="0"/>
+          <a:ext cx="0" cy="0"/>
+          <a:chOff x="0" y="0"/>
+          <a:chExt cx="0" cy="0"/>
+        </a:xfrm>
+      </p:grpSpPr>
       <p:pic>
         <p:nvPicPr>
           <p:cNvPr id="2" name="Picture 1" descr="page-26.png"/>
@@ -3905,7 +4815,7 @@
 </file>
 
 <file path=ppt/slides/slide27.xml><?xml version="1.0" encoding="utf-8"?>
-<p:sld xmlns:a="http://schemas.openxmlformats.org/drawingml/2006/main" xmlns:p="http://schemas.openxmlformats.org/presentationml/2006/main" xmlns:r="http://schemas.openxmlformats.org/officeDocument/2006/relationships">
+<p:sld xmlns:a="http://schemas.openxmlformats.org/drawingml/2006/main" xmlns:r="http://schemas.openxmlformats.org/officeDocument/2006/relationships" xmlns:p="http://schemas.openxmlformats.org/presentationml/2006/main">
   <p:cSld>
     <p:spTree>
       <p:nvGrpSpPr>
@@ -3913,7 +4823,14 @@
         <p:cNvGrpSpPr/>
         <p:nvPr/>
       </p:nvGrpSpPr>
-      <p:grpSpPr/>
+      <p:grpSpPr>
+        <a:xfrm>
+          <a:off x="0" y="0"/>
+          <a:ext cx="0" cy="0"/>
+          <a:chOff x="0" y="0"/>
+          <a:chExt cx="0" cy="0"/>
+        </a:xfrm>
+      </p:grpSpPr>
       <p:pic>
         <p:nvPicPr>
           <p:cNvPr id="2" name="Picture 1" descr="page-27.png"/>
@@ -3947,7 +4864,7 @@
 </file>
 
 <file path=ppt/slides/slide28.xml><?xml version="1.0" encoding="utf-8"?>
-<p:sld xmlns:a="http://schemas.openxmlformats.org/drawingml/2006/main" xmlns:p="http://schemas.openxmlformats.org/presentationml/2006/main" xmlns:r="http://schemas.openxmlformats.org/officeDocument/2006/relationships">
+<p:sld xmlns:a="http://schemas.openxmlformats.org/drawingml/2006/main" xmlns:r="http://schemas.openxmlformats.org/officeDocument/2006/relationships" xmlns:p="http://schemas.openxmlformats.org/presentationml/2006/main">
   <p:cSld>
     <p:spTree>
       <p:nvGrpSpPr>
@@ -3955,7 +4872,14 @@
         <p:cNvGrpSpPr/>
         <p:nvPr/>
       </p:nvGrpSpPr>
-      <p:grpSpPr/>
+      <p:grpSpPr>
+        <a:xfrm>
+          <a:off x="0" y="0"/>
+          <a:ext cx="0" cy="0"/>
+          <a:chOff x="0" y="0"/>
+          <a:chExt cx="0" cy="0"/>
+        </a:xfrm>
+      </p:grpSpPr>
       <p:pic>
         <p:nvPicPr>
           <p:cNvPr id="2" name="Picture 1" descr="page-28.png"/>
@@ -3989,7 +4913,7 @@
 </file>
 
 <file path=ppt/slides/slide29.xml><?xml version="1.0" encoding="utf-8"?>
-<p:sld xmlns:a="http://schemas.openxmlformats.org/drawingml/2006/main" xmlns:p="http://schemas.openxmlformats.org/presentationml/2006/main" xmlns:r="http://schemas.openxmlformats.org/officeDocument/2006/relationships">
+<p:sld xmlns:a="http://schemas.openxmlformats.org/drawingml/2006/main" xmlns:r="http://schemas.openxmlformats.org/officeDocument/2006/relationships" xmlns:p="http://schemas.openxmlformats.org/presentationml/2006/main">
   <p:cSld>
     <p:spTree>
       <p:nvGrpSpPr>
@@ -3997,7 +4921,14 @@
         <p:cNvGrpSpPr/>
         <p:nvPr/>
       </p:nvGrpSpPr>
-      <p:grpSpPr/>
+      <p:grpSpPr>
+        <a:xfrm>
+          <a:off x="0" y="0"/>
+          <a:ext cx="0" cy="0"/>
+          <a:chOff x="0" y="0"/>
+          <a:chExt cx="0" cy="0"/>
+        </a:xfrm>
+      </p:grpSpPr>
       <p:pic>
         <p:nvPicPr>
           <p:cNvPr id="2" name="Picture 1" descr="page-29.png"/>
@@ -4031,7 +4962,7 @@
 </file>
 
 <file path=ppt/slides/slide3.xml><?xml version="1.0" encoding="utf-8"?>
-<p:sld xmlns:a="http://schemas.openxmlformats.org/drawingml/2006/main" xmlns:p="http://schemas.openxmlformats.org/presentationml/2006/main" xmlns:r="http://schemas.openxmlformats.org/officeDocument/2006/relationships">
+<p:sld xmlns:a="http://schemas.openxmlformats.org/drawingml/2006/main" xmlns:r="http://schemas.openxmlformats.org/officeDocument/2006/relationships" xmlns:p="http://schemas.openxmlformats.org/presentationml/2006/main">
   <p:cSld>
     <p:spTree>
       <p:nvGrpSpPr>
@@ -4039,7 +4970,14 @@
         <p:cNvGrpSpPr/>
         <p:nvPr/>
       </p:nvGrpSpPr>
-      <p:grpSpPr/>
+      <p:grpSpPr>
+        <a:xfrm>
+          <a:off x="0" y="0"/>
+          <a:ext cx="0" cy="0"/>
+          <a:chOff x="0" y="0"/>
+          <a:chExt cx="0" cy="0"/>
+        </a:xfrm>
+      </p:grpSpPr>
       <p:pic>
         <p:nvPicPr>
           <p:cNvPr id="2" name="Picture 1" descr="page-03.png"/>
@@ -4073,7 +5011,7 @@
 </file>
 
 <file path=ppt/slides/slide4.xml><?xml version="1.0" encoding="utf-8"?>
-<p:sld xmlns:a="http://schemas.openxmlformats.org/drawingml/2006/main" xmlns:p="http://schemas.openxmlformats.org/presentationml/2006/main" xmlns:r="http://schemas.openxmlformats.org/officeDocument/2006/relationships">
+<p:sld xmlns:a="http://schemas.openxmlformats.org/drawingml/2006/main" xmlns:r="http://schemas.openxmlformats.org/officeDocument/2006/relationships" xmlns:p="http://schemas.openxmlformats.org/presentationml/2006/main">
   <p:cSld>
     <p:spTree>
       <p:nvGrpSpPr>
@@ -4081,7 +5019,14 @@
         <p:cNvGrpSpPr/>
         <p:nvPr/>
       </p:nvGrpSpPr>
-      <p:grpSpPr/>
+      <p:grpSpPr>
+        <a:xfrm>
+          <a:off x="0" y="0"/>
+          <a:ext cx="0" cy="0"/>
+          <a:chOff x="0" y="0"/>
+          <a:chExt cx="0" cy="0"/>
+        </a:xfrm>
+      </p:grpSpPr>
       <p:pic>
         <p:nvPicPr>
           <p:cNvPr id="2" name="Picture 1" descr="page-04.png"/>
@@ -4115,7 +5060,7 @@
 </file>
 
 <file path=ppt/slides/slide5.xml><?xml version="1.0" encoding="utf-8"?>
-<p:sld xmlns:a="http://schemas.openxmlformats.org/drawingml/2006/main" xmlns:p="http://schemas.openxmlformats.org/presentationml/2006/main" xmlns:r="http://schemas.openxmlformats.org/officeDocument/2006/relationships">
+<p:sld xmlns:a="http://schemas.openxmlformats.org/drawingml/2006/main" xmlns:r="http://schemas.openxmlformats.org/officeDocument/2006/relationships" xmlns:p="http://schemas.openxmlformats.org/presentationml/2006/main">
   <p:cSld>
     <p:spTree>
       <p:nvGrpSpPr>
@@ -4123,7 +5068,14 @@
         <p:cNvGrpSpPr/>
         <p:nvPr/>
       </p:nvGrpSpPr>
-      <p:grpSpPr/>
+      <p:grpSpPr>
+        <a:xfrm>
+          <a:off x="0" y="0"/>
+          <a:ext cx="0" cy="0"/>
+          <a:chOff x="0" y="0"/>
+          <a:chExt cx="0" cy="0"/>
+        </a:xfrm>
+      </p:grpSpPr>
       <p:pic>
         <p:nvPicPr>
           <p:cNvPr id="2" name="Picture 1" descr="page-05.png"/>
@@ -4157,7 +5109,7 @@
 </file>
 
 <file path=ppt/slides/slide6.xml><?xml version="1.0" encoding="utf-8"?>
-<p:sld xmlns:a="http://schemas.openxmlformats.org/drawingml/2006/main" xmlns:p="http://schemas.openxmlformats.org/presentationml/2006/main" xmlns:r="http://schemas.openxmlformats.org/officeDocument/2006/relationships">
+<p:sld xmlns:a="http://schemas.openxmlformats.org/drawingml/2006/main" xmlns:r="http://schemas.openxmlformats.org/officeDocument/2006/relationships" xmlns:p="http://schemas.openxmlformats.org/presentationml/2006/main">
   <p:cSld>
     <p:spTree>
       <p:nvGrpSpPr>
@@ -4165,7 +5117,14 @@
         <p:cNvGrpSpPr/>
         <p:nvPr/>
       </p:nvGrpSpPr>
-      <p:grpSpPr/>
+      <p:grpSpPr>
+        <a:xfrm>
+          <a:off x="0" y="0"/>
+          <a:ext cx="0" cy="0"/>
+          <a:chOff x="0" y="0"/>
+          <a:chExt cx="0" cy="0"/>
+        </a:xfrm>
+      </p:grpSpPr>
       <p:pic>
         <p:nvPicPr>
           <p:cNvPr id="2" name="Picture 1" descr="page-06.png"/>
@@ -4199,7 +5158,7 @@
 </file>
 
 <file path=ppt/slides/slide7.xml><?xml version="1.0" encoding="utf-8"?>
-<p:sld xmlns:a="http://schemas.openxmlformats.org/drawingml/2006/main" xmlns:p="http://schemas.openxmlformats.org/presentationml/2006/main" xmlns:r="http://schemas.openxmlformats.org/officeDocument/2006/relationships">
+<p:sld xmlns:a="http://schemas.openxmlformats.org/drawingml/2006/main" xmlns:r="http://schemas.openxmlformats.org/officeDocument/2006/relationships" xmlns:p="http://schemas.openxmlformats.org/presentationml/2006/main">
   <p:cSld>
     <p:spTree>
       <p:nvGrpSpPr>
@@ -4207,7 +5166,14 @@
         <p:cNvGrpSpPr/>
         <p:nvPr/>
       </p:nvGrpSpPr>
-      <p:grpSpPr/>
+      <p:grpSpPr>
+        <a:xfrm>
+          <a:off x="0" y="0"/>
+          <a:ext cx="0" cy="0"/>
+          <a:chOff x="0" y="0"/>
+          <a:chExt cx="0" cy="0"/>
+        </a:xfrm>
+      </p:grpSpPr>
       <p:pic>
         <p:nvPicPr>
           <p:cNvPr id="2" name="Picture 1" descr="page-07.png"/>
@@ -4241,7 +5207,7 @@
 </file>
 
 <file path=ppt/slides/slide8.xml><?xml version="1.0" encoding="utf-8"?>
-<p:sld xmlns:a="http://schemas.openxmlformats.org/drawingml/2006/main" xmlns:p="http://schemas.openxmlformats.org/presentationml/2006/main" xmlns:r="http://schemas.openxmlformats.org/officeDocument/2006/relationships">
+<p:sld xmlns:a="http://schemas.openxmlformats.org/drawingml/2006/main" xmlns:r="http://schemas.openxmlformats.org/officeDocument/2006/relationships" xmlns:p="http://schemas.openxmlformats.org/presentationml/2006/main">
   <p:cSld>
     <p:spTree>
       <p:nvGrpSpPr>
@@ -4249,7 +5215,14 @@
         <p:cNvGrpSpPr/>
         <p:nvPr/>
       </p:nvGrpSpPr>
-      <p:grpSpPr/>
+      <p:grpSpPr>
+        <a:xfrm>
+          <a:off x="0" y="0"/>
+          <a:ext cx="0" cy="0"/>
+          <a:chOff x="0" y="0"/>
+          <a:chExt cx="0" cy="0"/>
+        </a:xfrm>
+      </p:grpSpPr>
       <p:pic>
         <p:nvPicPr>
           <p:cNvPr id="2" name="Picture 1" descr="page-08.png"/>
@@ -4283,7 +5256,7 @@
 </file>
 
 <file path=ppt/slides/slide9.xml><?xml version="1.0" encoding="utf-8"?>
-<p:sld xmlns:a="http://schemas.openxmlformats.org/drawingml/2006/main" xmlns:p="http://schemas.openxmlformats.org/presentationml/2006/main" xmlns:r="http://schemas.openxmlformats.org/officeDocument/2006/relationships">
+<p:sld xmlns:a="http://schemas.openxmlformats.org/drawingml/2006/main" xmlns:r="http://schemas.openxmlformats.org/officeDocument/2006/relationships" xmlns:p="http://schemas.openxmlformats.org/presentationml/2006/main">
   <p:cSld>
     <p:spTree>
       <p:nvGrpSpPr>
@@ -4291,7 +5264,14 @@
         <p:cNvGrpSpPr/>
         <p:nvPr/>
       </p:nvGrpSpPr>
-      <p:grpSpPr/>
+      <p:grpSpPr>
+        <a:xfrm>
+          <a:off x="0" y="0"/>
+          <a:ext cx="0" cy="0"/>
+          <a:chOff x="0" y="0"/>
+          <a:chExt cx="0" cy="0"/>
+        </a:xfrm>
+      </p:grpSpPr>
       <p:pic>
         <p:nvPicPr>
           <p:cNvPr id="2" name="Picture 1" descr="page-09.png"/>
@@ -4642,4 +5622,299 @@
   </a:objectDefaults>
   <a:extraClrSchemeLst/>
 </a:theme>
+</file>
+
+<file path=ppt/theme/theme2.xml><?xml version="1.0" encoding="utf-8"?>
+<a:theme xmlns:a="http://schemas.openxmlformats.org/drawingml/2006/main" name="Office Theme">
+  <a:themeElements>
+    <a:clrScheme name="Office">
+      <a:dk1>
+        <a:sysClr val="windowText" lastClr="000000"/>
+      </a:dk1>
+      <a:lt1>
+        <a:sysClr val="window" lastClr="FFFFFF"/>
+      </a:lt1>
+      <a:dk2>
+        <a:srgbClr val="44546A"/>
+      </a:dk2>
+      <a:lt2>
+        <a:srgbClr val="E7E6E6"/>
+      </a:lt2>
+      <a:accent1>
+        <a:srgbClr val="4472C4"/>
+      </a:accent1>
+      <a:accent2>
+        <a:srgbClr val="ED7D31"/>
+      </a:accent2>
+      <a:accent3>
+        <a:srgbClr val="A5A5A5"/>
+      </a:accent3>
+      <a:accent4>
+        <a:srgbClr val="FFC000"/>
+      </a:accent4>
+      <a:accent5>
+        <a:srgbClr val="5B9BD5"/>
+      </a:accent5>
+      <a:accent6>
+        <a:srgbClr val="70AD47"/>
+      </a:accent6>
+      <a:hlink>
+        <a:srgbClr val="0563C1"/>
+      </a:hlink>
+      <a:folHlink>
+        <a:srgbClr val="954F72"/>
+      </a:folHlink>
+    </a:clrScheme>
+    <a:fontScheme name="Office">
+      <a:majorFont>
+        <a:latin typeface="Calibri Light" panose="020F0302020204030204"/>
+        <a:ea typeface=""/>
+        <a:cs typeface=""/>
+        <a:font script="Jpan" typeface="游ゴシック Light"/>
+        <a:font script="Hang" typeface="맑은 고딕"/>
+        <a:font script="Hans" typeface="等线 Light"/>
+        <a:font script="Hant" typeface="新細明體"/>
+        <a:font script="Arab" typeface="Times New Roman"/>
+        <a:font script="Hebr" typeface="Times New Roman"/>
+        <a:font script="Thai" typeface="Angsana New"/>
+        <a:font script="Ethi" typeface="Nyala"/>
+        <a:font script="Beng" typeface="Vrinda"/>
+        <a:font script="Gujr" typeface="Shruti"/>
+        <a:font script="Khmr" typeface="MoolBoran"/>
+        <a:font script="Knda" typeface="Tunga"/>
+        <a:font script="Guru" typeface="Raavi"/>
+        <a:font script="Cans" typeface="Euphemia"/>
+        <a:font script="Cher" typeface="Plantagenet Cherokee"/>
+        <a:font script="Yiii" typeface="Microsoft Yi Baiti"/>
+        <a:font script="Tibt" typeface="Microsoft Himalaya"/>
+        <a:font script="Thaa" typeface="MV Boli"/>
+        <a:font script="Deva" typeface="Mangal"/>
+        <a:font script="Telu" typeface="Gautami"/>
+        <a:font script="Taml" typeface="Latha"/>
+        <a:font script="Syrc" typeface="Estrangelo Edessa"/>
+        <a:font script="Orya" typeface="Kalinga"/>
+        <a:font script="Mlym" typeface="Kartika"/>
+        <a:font script="Laoo" typeface="DokChampa"/>
+        <a:font script="Sinh" typeface="Iskoola Pota"/>
+        <a:font script="Mong" typeface="Mongolian Baiti"/>
+        <a:font script="Viet" typeface="Times New Roman"/>
+        <a:font script="Uigh" typeface="Microsoft Uighur"/>
+        <a:font script="Geor" typeface="Sylfaen"/>
+        <a:font script="Armn" typeface="Arial"/>
+        <a:font script="Bugi" typeface="Leelawadee UI"/>
+        <a:font script="Bopo" typeface="Microsoft JhengHei"/>
+        <a:font script="Java" typeface="Javanese Text"/>
+        <a:font script="Lisu" typeface="Segoe UI"/>
+        <a:font script="Mymr" typeface="Myanmar Text"/>
+        <a:font script="Nkoo" typeface="Ebrima"/>
+        <a:font script="Olck" typeface="Nirmala UI"/>
+        <a:font script="Osma" typeface="Ebrima"/>
+        <a:font script="Phag" typeface="Phagspa"/>
+        <a:font script="Syrn" typeface="Estrangelo Edessa"/>
+        <a:font script="Syrj" typeface="Estrangelo Edessa"/>
+        <a:font script="Syre" typeface="Estrangelo Edessa"/>
+        <a:font script="Sora" typeface="Nirmala UI"/>
+        <a:font script="Tale" typeface="Microsoft Tai Le"/>
+        <a:font script="Talu" typeface="Microsoft New Tai Lue"/>
+        <a:font script="Tfng" typeface="Ebrima"/>
+      </a:majorFont>
+      <a:minorFont>
+        <a:latin typeface="Calibri" panose="020F0502020204030204"/>
+        <a:ea typeface=""/>
+        <a:cs typeface=""/>
+        <a:font script="Jpan" typeface="游ゴシック"/>
+        <a:font script="Hang" typeface="맑은 고딕"/>
+        <a:font script="Hans" typeface="等线"/>
+        <a:font script="Hant" typeface="新細明體"/>
+        <a:font script="Arab" typeface="Arial"/>
+        <a:font script="Hebr" typeface="Arial"/>
+        <a:font script="Thai" typeface="Cordia New"/>
+        <a:font script="Ethi" typeface="Nyala"/>
+        <a:font script="Beng" typeface="Vrinda"/>
+        <a:font script="Gujr" typeface="Shruti"/>
+        <a:font script="Khmr" typeface="DaunPenh"/>
+        <a:font script="Knda" typeface="Tunga"/>
+        <a:font script="Guru" typeface="Raavi"/>
+        <a:font script="Cans" typeface="Euphemia"/>
+        <a:font script="Cher" typeface="Plantagenet Cherokee"/>
+        <a:font script="Yiii" typeface="Microsoft Yi Baiti"/>
+        <a:font script="Tibt" typeface="Microsoft Himalaya"/>
+        <a:font script="Thaa" typeface="MV Boli"/>
+        <a:font script="Deva" typeface="Mangal"/>
+        <a:font script="Telu" typeface="Gautami"/>
+        <a:font script="Taml" typeface="Latha"/>
+        <a:font script="Syrc" typeface="Estrangelo Edessa"/>
+        <a:font script="Orya" typeface="Kalinga"/>
+        <a:font script="Mlym" typeface="Kartika"/>
+        <a:font script="Laoo" typeface="DokChampa"/>
+        <a:font script="Sinh" typeface="Iskoola Pota"/>
+        <a:font script="Mong" typeface="Mongolian Baiti"/>
+        <a:font script="Viet" typeface="Arial"/>
+        <a:font script="Uigh" typeface="Microsoft Uighur"/>
+        <a:font script="Geor" typeface="Sylfaen"/>
+        <a:font script="Armn" typeface="Arial"/>
+        <a:font script="Bugi" typeface="Leelawadee UI"/>
+        <a:font script="Bopo" typeface="Microsoft JhengHei"/>
+        <a:font script="Java" typeface="Javanese Text"/>
+        <a:font script="Lisu" typeface="Segoe UI"/>
+        <a:font script="Mymr" typeface="Myanmar Text"/>
+        <a:font script="Nkoo" typeface="Ebrima"/>
+        <a:font script="Olck" typeface="Nirmala UI"/>
+        <a:font script="Osma" typeface="Ebrima"/>
+        <a:font script="Phag" typeface="Phagspa"/>
+        <a:font script="Syrn" typeface="Estrangelo Edessa"/>
+        <a:font script="Syrj" typeface="Estrangelo Edessa"/>
+        <a:font script="Syre" typeface="Estrangelo Edessa"/>
+        <a:font script="Sora" typeface="Nirmala UI"/>
+        <a:font script="Tale" typeface="Microsoft Tai Le"/>
+        <a:font script="Talu" typeface="Microsoft New Tai Lue"/>
+        <a:font script="Tfng" typeface="Ebrima"/>
+      </a:minorFont>
+    </a:fontScheme>
+    <a:fmtScheme name="Office">
+      <a:fillStyleLst>
+        <a:solidFill>
+          <a:schemeClr val="phClr"/>
+        </a:solidFill>
+        <a:gradFill rotWithShape="1">
+          <a:gsLst>
+            <a:gs pos="0">
+              <a:schemeClr val="phClr">
+                <a:lumMod val="110000"/>
+                <a:satMod val="105000"/>
+                <a:tint val="67000"/>
+              </a:schemeClr>
+            </a:gs>
+            <a:gs pos="50000">
+              <a:schemeClr val="phClr">
+                <a:lumMod val="105000"/>
+                <a:satMod val="103000"/>
+                <a:tint val="73000"/>
+              </a:schemeClr>
+            </a:gs>
+            <a:gs pos="100000">
+              <a:schemeClr val="phClr">
+                <a:lumMod val="105000"/>
+                <a:satMod val="109000"/>
+                <a:tint val="81000"/>
+              </a:schemeClr>
+            </a:gs>
+          </a:gsLst>
+          <a:lin ang="5400000" scaled="0"/>
+        </a:gradFill>
+        <a:gradFill rotWithShape="1">
+          <a:gsLst>
+            <a:gs pos="0">
+              <a:schemeClr val="phClr">
+                <a:satMod val="103000"/>
+                <a:lumMod val="102000"/>
+                <a:tint val="94000"/>
+              </a:schemeClr>
+            </a:gs>
+            <a:gs pos="50000">
+              <a:schemeClr val="phClr">
+                <a:satMod val="110000"/>
+                <a:lumMod val="100000"/>
+                <a:shade val="100000"/>
+              </a:schemeClr>
+            </a:gs>
+            <a:gs pos="100000">
+              <a:schemeClr val="phClr">
+                <a:lumMod val="99000"/>
+                <a:satMod val="120000"/>
+                <a:shade val="78000"/>
+              </a:schemeClr>
+            </a:gs>
+          </a:gsLst>
+          <a:lin ang="5400000" scaled="0"/>
+        </a:gradFill>
+      </a:fillStyleLst>
+      <a:lnStyleLst>
+        <a:ln w="6350" cap="flat" cmpd="sng" algn="ctr">
+          <a:solidFill>
+            <a:schemeClr val="phClr"/>
+          </a:solidFill>
+          <a:prstDash val="solid"/>
+          <a:miter lim="800000"/>
+        </a:ln>
+        <a:ln w="12700" cap="flat" cmpd="sng" algn="ctr">
+          <a:solidFill>
+            <a:schemeClr val="phClr"/>
+          </a:solidFill>
+          <a:prstDash val="solid"/>
+          <a:miter lim="800000"/>
+        </a:ln>
+        <a:ln w="19050" cap="flat" cmpd="sng" algn="ctr">
+          <a:solidFill>
+            <a:schemeClr val="phClr"/>
+          </a:solidFill>
+          <a:prstDash val="solid"/>
+          <a:miter lim="800000"/>
+        </a:ln>
+      </a:lnStyleLst>
+      <a:effectStyleLst>
+        <a:effectStyle>
+          <a:effectLst/>
+        </a:effectStyle>
+        <a:effectStyle>
+          <a:effectLst/>
+        </a:effectStyle>
+        <a:effectStyle>
+          <a:effectLst>
+            <a:outerShdw blurRad="57150" dist="19050" dir="5400000" algn="ctr" rotWithShape="0">
+              <a:srgbClr val="000000">
+                <a:alpha val="63000"/>
+              </a:srgbClr>
+            </a:outerShdw>
+          </a:effectLst>
+        </a:effectStyle>
+      </a:effectStyleLst>
+      <a:bgFillStyleLst>
+        <a:solidFill>
+          <a:schemeClr val="phClr"/>
+        </a:solidFill>
+        <a:solidFill>
+          <a:schemeClr val="phClr">
+            <a:tint val="95000"/>
+            <a:satMod val="170000"/>
+          </a:schemeClr>
+        </a:solidFill>
+        <a:gradFill rotWithShape="1">
+          <a:gsLst>
+            <a:gs pos="0">
+              <a:schemeClr val="phClr">
+                <a:tint val="93000"/>
+                <a:satMod val="150000"/>
+                <a:shade val="98000"/>
+                <a:lumMod val="102000"/>
+              </a:schemeClr>
+            </a:gs>
+            <a:gs pos="50000">
+              <a:schemeClr val="phClr">
+                <a:tint val="98000"/>
+                <a:satMod val="130000"/>
+                <a:shade val="90000"/>
+                <a:lumMod val="103000"/>
+              </a:schemeClr>
+            </a:gs>
+            <a:gs pos="100000">
+              <a:schemeClr val="phClr">
+                <a:shade val="63000"/>
+                <a:satMod val="120000"/>
+              </a:schemeClr>
+            </a:gs>
+          </a:gsLst>
+          <a:lin ang="5400000" scaled="0"/>
+        </a:gradFill>
+      </a:bgFillStyleLst>
+    </a:fmtScheme>
+  </a:themeElements>
+  <a:objectDefaults/>
+  <a:extraClrSchemeLst/>
+  <a:extLst>
+    <a:ext uri="{05A4C25C-085E-4340-85A3-A5531E510DB2}">
+      <thm15:themeFamily xmlns:thm15="http://schemas.microsoft.com/office/thememl/2012/main" name="Office Theme" id="{62F939B6-93AF-4DB8-9C6B-D6C7DFDC589F}" vid="{4A3C46E8-61CC-4603-A589-7422A47A8E4A}"/>
+    </a:ext>
+  </a:extLst>
+</a:theme>
 </file>
</xml_diff>